<commit_message>
Deck rebuild: denser layout aligned with rulebook §6
EDA deck (eda_2pm) and pitch deck (pitch_6pm) reworked with stat-hero
cards, colored callouts (TRAFFIC/WEATHER/VERDICT), before-vs-after
cleaning comparison, BURIED-INSIGHT callout on the SHAP slide.

Every number on every slide is read live from eda_summary.json /
scores_v1*.json / shap_top.json. No hard-coded results (rulebook §6).
No [VALUE] placeholders. Every figure has a caption + takeaway.

Pitch slide 6/7 (Pivot / Delta) now show the decision framework
pre-15:00 instead of an empty "Awaiting" placeholder.

Co-Authored-By: Claude Sonnet 4.6 <noreply@anthropic.com>
</commit_message>
<xml_diff>
--- a/reports/eda_2pm.pptx
+++ b/reports/eda_2pm.pptx
@@ -3468,8 +3468,123 @@
         </p:nvSpPr>
         <p:spPr>
           <a:xfrm>
-            <a:off x="548640" y="1463040"/>
-            <a:ext cx="10972800" cy="4846320"/>
+            <a:off x="548640" y="914400"/>
+            <a:ext cx="10972800" cy="457200"/>
+          </a:xfrm>
+          <a:prstGeom prst="rect">
+            <a:avLst/>
+          </a:prstGeom>
+          <a:noFill/>
+        </p:spPr>
+        <p:txBody>
+          <a:bodyPr wrap="none">
+            <a:spAutoFit/>
+          </a:bodyPr>
+          <a:lstStyle/>
+          <a:p>
+            <a:pPr>
+              <a:defRPr sz="1400" i="1">
+                <a:solidFill>
+                  <a:srgbClr val="2DD4BF"/>
+                </a:solidFill>
+              </a:defRPr>
+            </a:pPr>
+            <a:r>
+              <a:t>Concrete extensions, not vague aspirations.</a:t>
+            </a:r>
+          </a:p>
+        </p:txBody>
+      </p:sp>
+      <p:sp>
+        <p:nvSpPr>
+          <p:cNvPr id="6" name="Rectangle 5"/>
+          <p:cNvSpPr/>
+          <p:nvPr/>
+        </p:nvSpPr>
+        <p:spPr>
+          <a:xfrm>
+            <a:off x="502920" y="1371600"/>
+            <a:ext cx="5486400" cy="4937760"/>
+          </a:xfrm>
+          <a:prstGeom prst="rect">
+            <a:avLst/>
+          </a:prstGeom>
+          <a:solidFill>
+            <a:srgbClr val="12304A"/>
+          </a:solidFill>
+          <a:ln w="12700">
+            <a:solidFill>
+              <a:srgbClr val="2DD4BF"/>
+            </a:solidFill>
+          </a:ln>
+        </p:spPr>
+        <p:style>
+          <a:lnRef idx="1">
+            <a:schemeClr val="accent1"/>
+          </a:lnRef>
+          <a:fillRef idx="3">
+            <a:schemeClr val="accent1"/>
+          </a:fillRef>
+          <a:effectRef idx="2">
+            <a:schemeClr val="accent1"/>
+          </a:effectRef>
+          <a:fontRef idx="minor">
+            <a:schemeClr val="lt1"/>
+          </a:fontRef>
+        </p:style>
+        <p:txBody>
+          <a:bodyPr rtlCol="0" anchor="ctr"/>
+          <a:lstStyle/>
+          <a:p>
+            <a:pPr algn="ctr"/>
+          </a:p>
+        </p:txBody>
+      </p:sp>
+      <p:sp>
+        <p:nvSpPr>
+          <p:cNvPr id="7" name="TextBox 6"/>
+          <p:cNvSpPr txBox="1"/>
+          <p:nvPr/>
+        </p:nvSpPr>
+        <p:spPr>
+          <a:xfrm>
+            <a:off x="640080" y="1463040"/>
+            <a:ext cx="5212080" cy="320040"/>
+          </a:xfrm>
+          <a:prstGeom prst="rect">
+            <a:avLst/>
+          </a:prstGeom>
+          <a:noFill/>
+        </p:spPr>
+        <p:txBody>
+          <a:bodyPr wrap="square">
+            <a:spAutoFit/>
+          </a:bodyPr>
+          <a:lstStyle/>
+          <a:p>
+            <a:pPr algn="l">
+              <a:defRPr sz="1200" b="1" i="0">
+                <a:solidFill>
+                  <a:srgbClr val="2DD4BF"/>
+                </a:solidFill>
+              </a:defRPr>
+            </a:pPr>
+            <a:r>
+              <a:t>DATA  &amp;  FEATURES</a:t>
+            </a:r>
+          </a:p>
+        </p:txBody>
+      </p:sp>
+      <p:sp>
+        <p:nvSpPr>
+          <p:cNvPr id="8" name="TextBox 7"/>
+          <p:cNvSpPr txBox="1"/>
+          <p:nvPr/>
+        </p:nvSpPr>
+        <p:spPr>
+          <a:xfrm>
+            <a:off x="640080" y="1874519"/>
+            <a:ext cx="5303520" cy="4297680"/>
           </a:xfrm>
           <a:prstGeom prst="rect">
             <a:avLst/>
@@ -3486,14 +3601,14 @@
               <a:spcAft>
                 <a:spcPts val="800"/>
               </a:spcAft>
-              <a:defRPr sz="1800">
+              <a:defRPr sz="1200">
                 <a:solidFill>
                   <a:srgbClr val="FFFFFF"/>
                 </a:solidFill>
               </a:defRPr>
             </a:pPr>
             <a:r>
-              <a:t>•  Real-time traffic API as a feature (we already know it's the strongest signal).</a:t>
+              <a:t>•  Real-time traffic API — SHAP shows traffic is #1; live data uncaps it.</a:t>
             </a:r>
           </a:p>
           <a:p>
@@ -3501,14 +3616,14 @@
               <a:spcAft>
                 <a:spcPts val="800"/>
               </a:spcAft>
-              <a:defRPr sz="1800">
+              <a:defRPr sz="1200">
                 <a:solidFill>
                   <a:srgbClr val="FFFFFF"/>
                 </a:solidFill>
               </a:defRPr>
             </a:pPr>
             <a:r>
-              <a:t>•  Restaurant prep-time history: rolling mean per restaurant_id.</a:t>
+              <a:t>•  Restaurant prep-time rolling mean (per restaurant_id × hour).</a:t>
             </a:r>
           </a:p>
           <a:p>
@@ -3516,14 +3631,14 @@
               <a:spcAft>
                 <a:spcPts val="800"/>
               </a:spcAft>
-              <a:defRPr sz="1800">
+              <a:defRPr sz="1200">
                 <a:solidFill>
                   <a:srgbClr val="FFFFFF"/>
                 </a:solidFill>
               </a:defRPr>
             </a:pPr>
             <a:r>
-              <a:t>•  Quantile regression for ETA intervals, not just point predictions.</a:t>
+              <a:t>•  Rider-history: avg delivery time over their last N orders.</a:t>
             </a:r>
           </a:p>
           <a:p>
@@ -3531,21 +3646,214 @@
               <a:spcAft>
                 <a:spcPts val="800"/>
               </a:spcAft>
-              <a:defRPr sz="1800">
+              <a:defRPr sz="1200">
                 <a:solidFill>
                   <a:srgbClr val="FFFFFF"/>
                 </a:solidFill>
               </a:defRPr>
             </a:pPr>
             <a:r>
+              <a:t>•  Weather severity numeric (intensity, not just category).</a:t>
+            </a:r>
+          </a:p>
+          <a:p>
+            <a:pPr>
+              <a:spcAft>
+                <a:spcPts val="800"/>
+              </a:spcAft>
+              <a:defRPr sz="1200">
+                <a:solidFill>
+                  <a:srgbClr val="FFFFFF"/>
+                </a:solidFill>
+              </a:defRPr>
+            </a:pPr>
+            <a:r>
+              <a:t>•  City demand index — orders per hour as a zone feature.</a:t>
+            </a:r>
+          </a:p>
+        </p:txBody>
+      </p:sp>
+      <p:sp>
+        <p:nvSpPr>
+          <p:cNvPr id="9" name="Rectangle 8"/>
+          <p:cNvSpPr/>
+          <p:nvPr/>
+        </p:nvSpPr>
+        <p:spPr>
+          <a:xfrm>
+            <a:off x="6263640" y="1371600"/>
+            <a:ext cx="5486400" cy="4937760"/>
+          </a:xfrm>
+          <a:prstGeom prst="rect">
+            <a:avLst/>
+          </a:prstGeom>
+          <a:solidFill>
+            <a:srgbClr val="12304A"/>
+          </a:solidFill>
+          <a:ln w="12700">
+            <a:solidFill>
+              <a:srgbClr val="FACC15"/>
+            </a:solidFill>
+          </a:ln>
+        </p:spPr>
+        <p:style>
+          <a:lnRef idx="1">
+            <a:schemeClr val="accent1"/>
+          </a:lnRef>
+          <a:fillRef idx="3">
+            <a:schemeClr val="accent1"/>
+          </a:fillRef>
+          <a:effectRef idx="2">
+            <a:schemeClr val="accent1"/>
+          </a:effectRef>
+          <a:fontRef idx="minor">
+            <a:schemeClr val="lt1"/>
+          </a:fontRef>
+        </p:style>
+        <p:txBody>
+          <a:bodyPr rtlCol="0" anchor="ctr"/>
+          <a:lstStyle/>
+          <a:p>
+            <a:pPr algn="ctr"/>
+          </a:p>
+        </p:txBody>
+      </p:sp>
+      <p:sp>
+        <p:nvSpPr>
+          <p:cNvPr id="10" name="TextBox 9"/>
+          <p:cNvSpPr txBox="1"/>
+          <p:nvPr/>
+        </p:nvSpPr>
+        <p:spPr>
+          <a:xfrm>
+            <a:off x="6400800" y="1463040"/>
+            <a:ext cx="5212080" cy="320040"/>
+          </a:xfrm>
+          <a:prstGeom prst="rect">
+            <a:avLst/>
+          </a:prstGeom>
+          <a:noFill/>
+        </p:spPr>
+        <p:txBody>
+          <a:bodyPr wrap="square">
+            <a:spAutoFit/>
+          </a:bodyPr>
+          <a:lstStyle/>
+          <a:p>
+            <a:pPr algn="l">
+              <a:defRPr sz="1200" b="1" i="0">
+                <a:solidFill>
+                  <a:srgbClr val="FACC15"/>
+                </a:solidFill>
+              </a:defRPr>
+            </a:pPr>
+            <a:r>
+              <a:t>MODEL  &amp;  OUTPUT</a:t>
+            </a:r>
+          </a:p>
+        </p:txBody>
+      </p:sp>
+      <p:sp>
+        <p:nvSpPr>
+          <p:cNvPr id="11" name="TextBox 10"/>
+          <p:cNvSpPr txBox="1"/>
+          <p:nvPr/>
+        </p:nvSpPr>
+        <p:spPr>
+          <a:xfrm>
+            <a:off x="6400800" y="1874519"/>
+            <a:ext cx="5303520" cy="4297680"/>
+          </a:xfrm>
+          <a:prstGeom prst="rect">
+            <a:avLst/>
+          </a:prstGeom>
+          <a:noFill/>
+        </p:spPr>
+        <p:txBody>
+          <a:bodyPr wrap="square">
+            <a:spAutoFit/>
+          </a:bodyPr>
+          <a:lstStyle/>
+          <a:p>
+            <a:pPr>
+              <a:spcAft>
+                <a:spcPts val="800"/>
+              </a:spcAft>
+              <a:defRPr sz="1200">
+                <a:solidFill>
+                  <a:srgbClr val="FFFFFF"/>
+                </a:solidFill>
+              </a:defRPr>
+            </a:pPr>
+            <a:r>
+              <a:t>•  Quantile regression — give an ETA RANGE, not a point.</a:t>
+            </a:r>
+          </a:p>
+          <a:p>
+            <a:pPr>
+              <a:spcAft>
+                <a:spcPts val="800"/>
+              </a:spcAft>
+              <a:defRPr sz="1200">
+                <a:solidFill>
+                  <a:srgbClr val="FFFFFF"/>
+                </a:solidFill>
+              </a:defRPr>
+            </a:pPr>
+            <a:r>
               <a:t>•  Stack the existing blend: LGBM (3.05) + CatBoost (3.09) → blend 3.04.</a:t>
             </a:r>
           </a:p>
-        </p:txBody>
-      </p:sp>
-      <p:sp>
-        <p:nvSpPr>
-          <p:cNvPr id="6" name="TextBox 5"/>
+          <a:p>
+            <a:pPr>
+              <a:spcAft>
+                <a:spcPts val="800"/>
+              </a:spcAft>
+              <a:defRPr sz="1200">
+                <a:solidFill>
+                  <a:srgbClr val="FFFFFF"/>
+                </a:solidFill>
+              </a:defRPr>
+            </a:pPr>
+            <a:r>
+              <a:t>•  Per-segment models (urban vs metropolitan) where distance flips.</a:t>
+            </a:r>
+          </a:p>
+          <a:p>
+            <a:pPr>
+              <a:spcAft>
+                <a:spcPts val="800"/>
+              </a:spcAft>
+              <a:defRPr sz="1200">
+                <a:solidFill>
+                  <a:srgbClr val="FFFFFF"/>
+                </a:solidFill>
+              </a:defRPr>
+            </a:pPr>
+            <a:r>
+              <a:t>•  Online learning: nightly re-fit on the last 7 days.</a:t>
+            </a:r>
+          </a:p>
+          <a:p>
+            <a:pPr>
+              <a:spcAft>
+                <a:spcPts val="800"/>
+              </a:spcAft>
+              <a:defRPr sz="1200">
+                <a:solidFill>
+                  <a:srgbClr val="FFFFFF"/>
+                </a:solidFill>
+              </a:defRPr>
+            </a:pPr>
+            <a:r>
+              <a:t>•  Calibration so the 90% interval actually covers 90%.</a:t>
+            </a:r>
+          </a:p>
+        </p:txBody>
+      </p:sp>
+      <p:sp>
+        <p:nvSpPr>
+          <p:cNvPr id="12" name="TextBox 11"/>
           <p:cNvSpPr txBox="1"/>
           <p:nvPr/>
         </p:nvSpPr>
@@ -3725,8 +4033,388 @@
         </p:nvSpPr>
         <p:spPr>
           <a:xfrm>
-            <a:off x="548640" y="1463040"/>
-            <a:ext cx="10972800" cy="4846320"/>
+            <a:off x="548640" y="914400"/>
+            <a:ext cx="10972800" cy="457200"/>
+          </a:xfrm>
+          <a:prstGeom prst="rect">
+            <a:avLst/>
+          </a:prstGeom>
+          <a:noFill/>
+        </p:spPr>
+        <p:txBody>
+          <a:bodyPr wrap="none">
+            <a:spAutoFit/>
+          </a:bodyPr>
+          <a:lstStyle/>
+          <a:p>
+            <a:pPr>
+              <a:defRPr sz="1400" i="1">
+                <a:solidFill>
+                  <a:srgbClr val="2DD4BF"/>
+                </a:solidFill>
+              </a:defRPr>
+            </a:pPr>
+            <a:r>
+              <a:t>Tabular regression on real delivery records — every minute saved is a happier customer.</a:t>
+            </a:r>
+          </a:p>
+        </p:txBody>
+      </p:sp>
+      <p:sp>
+        <p:nvSpPr>
+          <p:cNvPr id="6" name="Rectangle 5"/>
+          <p:cNvSpPr/>
+          <p:nvPr/>
+        </p:nvSpPr>
+        <p:spPr>
+          <a:xfrm>
+            <a:off x="502920" y="1417320"/>
+            <a:ext cx="3657600" cy="1463040"/>
+          </a:xfrm>
+          <a:prstGeom prst="rect">
+            <a:avLst/>
+          </a:prstGeom>
+          <a:solidFill>
+            <a:srgbClr val="12304A"/>
+          </a:solidFill>
+          <a:ln w="12700">
+            <a:solidFill>
+              <a:srgbClr val="0D9488"/>
+            </a:solidFill>
+          </a:ln>
+        </p:spPr>
+        <p:style>
+          <a:lnRef idx="1">
+            <a:schemeClr val="accent1"/>
+          </a:lnRef>
+          <a:fillRef idx="3">
+            <a:schemeClr val="accent1"/>
+          </a:fillRef>
+          <a:effectRef idx="2">
+            <a:schemeClr val="accent1"/>
+          </a:effectRef>
+          <a:fontRef idx="minor">
+            <a:schemeClr val="lt1"/>
+          </a:fontRef>
+        </p:style>
+        <p:txBody>
+          <a:bodyPr rtlCol="0" anchor="ctr"/>
+          <a:lstStyle/>
+          <a:p>
+            <a:pPr algn="ctr"/>
+          </a:p>
+        </p:txBody>
+      </p:sp>
+      <p:sp>
+        <p:nvSpPr>
+          <p:cNvPr id="7" name="TextBox 6"/>
+          <p:cNvSpPr txBox="1"/>
+          <p:nvPr/>
+        </p:nvSpPr>
+        <p:spPr>
+          <a:xfrm>
+            <a:off x="502920" y="1527048"/>
+            <a:ext cx="3657600" cy="804672"/>
+          </a:xfrm>
+          <a:prstGeom prst="rect">
+            <a:avLst/>
+          </a:prstGeom>
+          <a:noFill/>
+        </p:spPr>
+        <p:txBody>
+          <a:bodyPr wrap="square">
+            <a:spAutoFit/>
+          </a:bodyPr>
+          <a:lstStyle/>
+          <a:p>
+            <a:pPr algn="ctr">
+              <a:defRPr sz="2200" b="1" i="0">
+                <a:solidFill>
+                  <a:srgbClr val="2DD4BF"/>
+                </a:solidFill>
+              </a:defRPr>
+            </a:pPr>
+            <a:r>
+              <a:t>Time_taken (min)</a:t>
+            </a:r>
+          </a:p>
+        </p:txBody>
+      </p:sp>
+      <p:sp>
+        <p:nvSpPr>
+          <p:cNvPr id="8" name="TextBox 7"/>
+          <p:cNvSpPr txBox="1"/>
+          <p:nvPr/>
+        </p:nvSpPr>
+        <p:spPr>
+          <a:xfrm>
+            <a:off x="502920" y="2382926"/>
+            <a:ext cx="3657600" cy="438912"/>
+          </a:xfrm>
+          <a:prstGeom prst="rect">
+            <a:avLst/>
+          </a:prstGeom>
+          <a:noFill/>
+        </p:spPr>
+        <p:txBody>
+          <a:bodyPr wrap="square">
+            <a:spAutoFit/>
+          </a:bodyPr>
+          <a:lstStyle/>
+          <a:p>
+            <a:pPr algn="ctr">
+              <a:defRPr sz="1000" b="0" i="0">
+                <a:solidFill>
+                  <a:srgbClr val="94A3B8"/>
+                </a:solidFill>
+              </a:defRPr>
+            </a:pPr>
+            <a:r>
+              <a:t>TARGET COLUMN</a:t>
+            </a:r>
+          </a:p>
+        </p:txBody>
+      </p:sp>
+      <p:sp>
+        <p:nvSpPr>
+          <p:cNvPr id="9" name="Rectangle 8"/>
+          <p:cNvSpPr/>
+          <p:nvPr/>
+        </p:nvSpPr>
+        <p:spPr>
+          <a:xfrm>
+            <a:off x="4297680" y="1417320"/>
+            <a:ext cx="3657600" cy="1463040"/>
+          </a:xfrm>
+          <a:prstGeom prst="rect">
+            <a:avLst/>
+          </a:prstGeom>
+          <a:solidFill>
+            <a:srgbClr val="12304A"/>
+          </a:solidFill>
+          <a:ln w="12700">
+            <a:solidFill>
+              <a:srgbClr val="0D9488"/>
+            </a:solidFill>
+          </a:ln>
+        </p:spPr>
+        <p:style>
+          <a:lnRef idx="1">
+            <a:schemeClr val="accent1"/>
+          </a:lnRef>
+          <a:fillRef idx="3">
+            <a:schemeClr val="accent1"/>
+          </a:fillRef>
+          <a:effectRef idx="2">
+            <a:schemeClr val="accent1"/>
+          </a:effectRef>
+          <a:fontRef idx="minor">
+            <a:schemeClr val="lt1"/>
+          </a:fontRef>
+        </p:style>
+        <p:txBody>
+          <a:bodyPr rtlCol="0" anchor="ctr"/>
+          <a:lstStyle/>
+          <a:p>
+            <a:pPr algn="ctr"/>
+          </a:p>
+        </p:txBody>
+      </p:sp>
+      <p:sp>
+        <p:nvSpPr>
+          <p:cNvPr id="10" name="TextBox 9"/>
+          <p:cNvSpPr txBox="1"/>
+          <p:nvPr/>
+        </p:nvSpPr>
+        <p:spPr>
+          <a:xfrm>
+            <a:off x="4297680" y="1527048"/>
+            <a:ext cx="3657600" cy="804672"/>
+          </a:xfrm>
+          <a:prstGeom prst="rect">
+            <a:avLst/>
+          </a:prstGeom>
+          <a:noFill/>
+        </p:spPr>
+        <p:txBody>
+          <a:bodyPr wrap="square">
+            <a:spAutoFit/>
+          </a:bodyPr>
+          <a:lstStyle/>
+          <a:p>
+            <a:pPr algn="ctr">
+              <a:defRPr sz="2400" b="1" i="0">
+                <a:solidFill>
+                  <a:srgbClr val="2DD4BF"/>
+                </a:solidFill>
+              </a:defRPr>
+            </a:pPr>
+            <a:r>
+              <a:t>MAE</a:t>
+            </a:r>
+          </a:p>
+        </p:txBody>
+      </p:sp>
+      <p:sp>
+        <p:nvSpPr>
+          <p:cNvPr id="11" name="TextBox 10"/>
+          <p:cNvSpPr txBox="1"/>
+          <p:nvPr/>
+        </p:nvSpPr>
+        <p:spPr>
+          <a:xfrm>
+            <a:off x="4297680" y="2382926"/>
+            <a:ext cx="3657600" cy="438912"/>
+          </a:xfrm>
+          <a:prstGeom prst="rect">
+            <a:avLst/>
+          </a:prstGeom>
+          <a:noFill/>
+        </p:spPr>
+        <p:txBody>
+          <a:bodyPr wrap="square">
+            <a:spAutoFit/>
+          </a:bodyPr>
+          <a:lstStyle/>
+          <a:p>
+            <a:pPr algn="ctr">
+              <a:defRPr sz="1000" b="0" i="0">
+                <a:solidFill>
+                  <a:srgbClr val="94A3B8"/>
+                </a:solidFill>
+              </a:defRPr>
+            </a:pPr>
+            <a:r>
+              <a:t>METRIC  ·  lower is better</a:t>
+            </a:r>
+          </a:p>
+        </p:txBody>
+      </p:sp>
+      <p:sp>
+        <p:nvSpPr>
+          <p:cNvPr id="12" name="Rectangle 11"/>
+          <p:cNvSpPr/>
+          <p:nvPr/>
+        </p:nvSpPr>
+        <p:spPr>
+          <a:xfrm>
+            <a:off x="8092440" y="1417320"/>
+            <a:ext cx="3657600" cy="1463040"/>
+          </a:xfrm>
+          <a:prstGeom prst="rect">
+            <a:avLst/>
+          </a:prstGeom>
+          <a:solidFill>
+            <a:srgbClr val="12304A"/>
+          </a:solidFill>
+          <a:ln w="12700">
+            <a:solidFill>
+              <a:srgbClr val="FACC15"/>
+            </a:solidFill>
+          </a:ln>
+        </p:spPr>
+        <p:style>
+          <a:lnRef idx="1">
+            <a:schemeClr val="accent1"/>
+          </a:lnRef>
+          <a:fillRef idx="3">
+            <a:schemeClr val="accent1"/>
+          </a:fillRef>
+          <a:effectRef idx="2">
+            <a:schemeClr val="accent1"/>
+          </a:effectRef>
+          <a:fontRef idx="minor">
+            <a:schemeClr val="lt1"/>
+          </a:fontRef>
+        </p:style>
+        <p:txBody>
+          <a:bodyPr rtlCol="0" anchor="ctr"/>
+          <a:lstStyle/>
+          <a:p>
+            <a:pPr algn="ctr"/>
+          </a:p>
+        </p:txBody>
+      </p:sp>
+      <p:sp>
+        <p:nvSpPr>
+          <p:cNvPr id="13" name="TextBox 12"/>
+          <p:cNvSpPr txBox="1"/>
+          <p:nvPr/>
+        </p:nvSpPr>
+        <p:spPr>
+          <a:xfrm>
+            <a:off x="8092440" y="1527048"/>
+            <a:ext cx="3657600" cy="804672"/>
+          </a:xfrm>
+          <a:prstGeom prst="rect">
+            <a:avLst/>
+          </a:prstGeom>
+          <a:noFill/>
+        </p:spPr>
+        <p:txBody>
+          <a:bodyPr wrap="square">
+            <a:spAutoFit/>
+          </a:bodyPr>
+          <a:lstStyle/>
+          <a:p>
+            <a:pPr algn="ctr">
+              <a:defRPr sz="2400" b="1" i="0">
+                <a:solidFill>
+                  <a:srgbClr val="FACC15"/>
+                </a:solidFill>
+              </a:defRPr>
+            </a:pPr>
+            <a:r>
+              <a:t>3.05 min</a:t>
+            </a:r>
+          </a:p>
+        </p:txBody>
+      </p:sp>
+      <p:sp>
+        <p:nvSpPr>
+          <p:cNvPr id="14" name="TextBox 13"/>
+          <p:cNvSpPr txBox="1"/>
+          <p:nvPr/>
+        </p:nvSpPr>
+        <p:spPr>
+          <a:xfrm>
+            <a:off x="8092440" y="2382926"/>
+            <a:ext cx="3657600" cy="438912"/>
+          </a:xfrm>
+          <a:prstGeom prst="rect">
+            <a:avLst/>
+          </a:prstGeom>
+          <a:noFill/>
+        </p:spPr>
+        <p:txBody>
+          <a:bodyPr wrap="square">
+            <a:spAutoFit/>
+          </a:bodyPr>
+          <a:lstStyle/>
+          <a:p>
+            <a:pPr algn="ctr">
+              <a:defRPr sz="1000" b="0" i="0">
+                <a:solidFill>
+                  <a:srgbClr val="94A3B8"/>
+                </a:solidFill>
+              </a:defRPr>
+            </a:pPr>
+            <a:r>
+              <a:t>Our 5-fold tuned MAE</a:t>
+            </a:r>
+          </a:p>
+        </p:txBody>
+      </p:sp>
+      <p:sp>
+        <p:nvSpPr>
+          <p:cNvPr id="15" name="TextBox 14"/>
+          <p:cNvSpPr txBox="1"/>
+          <p:nvPr/>
+        </p:nvSpPr>
+        <p:spPr>
+          <a:xfrm>
+            <a:off x="502920" y="3154680"/>
+            <a:ext cx="11247120" cy="2194560"/>
           </a:xfrm>
           <a:prstGeom prst="rect">
             <a:avLst/>
@@ -3743,14 +4431,14 @@
               <a:spcAft>
                 <a:spcPts val="800"/>
               </a:spcAft>
-              <a:defRPr sz="2000">
+              <a:defRPr sz="1500">
                 <a:solidFill>
                   <a:srgbClr val="FFFFFF"/>
                 </a:solidFill>
               </a:defRPr>
             </a:pPr>
             <a:r>
-              <a:t>•  Goal: predict Time_taken (min) for each delivery — given order, rider, restaurant, and conditions.</a:t>
+              <a:t>•  Goal: predict the per-order delivery time given the order, rider, restaurant, traffic and weather.</a:t>
             </a:r>
           </a:p>
           <a:p>
@@ -3758,14 +4446,14 @@
               <a:spcAft>
                 <a:spcPts val="800"/>
               </a:spcAft>
-              <a:defRPr sz="2000">
+              <a:defRPr sz="1500">
                 <a:solidFill>
                   <a:srgbClr val="FFFFFF"/>
                 </a:solidFill>
               </a:defRPr>
             </a:pPr>
             <a:r>
-              <a:t>•  Metric: Mean Absolute Error (MAE). Lower is better.</a:t>
+              <a:t>•  Stakes: accurate ETAs build customer trust, balance courier load, and reduce refund volume.</a:t>
             </a:r>
           </a:p>
           <a:p>
@@ -3773,14 +4461,14 @@
               <a:spcAft>
                 <a:spcPts val="800"/>
               </a:spcAft>
-              <a:defRPr sz="2000">
+              <a:defRPr sz="1500">
                 <a:solidFill>
                   <a:srgbClr val="FFFFFF"/>
                 </a:solidFill>
               </a:defRPr>
             </a:pPr>
             <a:r>
-              <a:t>•  Stakes: accurate ETAs drive customer trust and let Zomato balance courier load in real time.</a:t>
+              <a:t>•  Naïve mean baseline → MAE ≈ 7.6 min. A 3-min model is a 60% relative error reduction over a dispatcher's gut feel.</a:t>
             </a:r>
           </a:p>
           <a:p>
@@ -3788,14 +4476,129 @@
               <a:spcAft>
                 <a:spcPts val="800"/>
               </a:spcAft>
-              <a:defRPr sz="2000">
+              <a:defRPr sz="1500">
                 <a:solidFill>
                   <a:srgbClr val="FFFFFF"/>
                 </a:solidFill>
               </a:defRPr>
             </a:pPr>
             <a:r>
-              <a:t>•  Baseline target: ≤4 min MAE; we are at 3.05 ± 0.02 min.</a:t>
+              <a:t>•  5-fold KFold (seed 42)  ·  honest OOF  ·  R² = 0.833.</a:t>
+            </a:r>
+          </a:p>
+        </p:txBody>
+      </p:sp>
+      <p:sp>
+        <p:nvSpPr>
+          <p:cNvPr id="16" name="Rectangle 15"/>
+          <p:cNvSpPr/>
+          <p:nvPr/>
+        </p:nvSpPr>
+        <p:spPr>
+          <a:xfrm>
+            <a:off x="502920" y="5532120"/>
+            <a:ext cx="11247120" cy="914400"/>
+          </a:xfrm>
+          <a:prstGeom prst="rect">
+            <a:avLst/>
+          </a:prstGeom>
+          <a:solidFill>
+            <a:srgbClr val="12304A"/>
+          </a:solidFill>
+          <a:ln w="12700">
+            <a:solidFill>
+              <a:srgbClr val="2DD4BF"/>
+            </a:solidFill>
+          </a:ln>
+        </p:spPr>
+        <p:style>
+          <a:lnRef idx="1">
+            <a:schemeClr val="accent1"/>
+          </a:lnRef>
+          <a:fillRef idx="3">
+            <a:schemeClr val="accent1"/>
+          </a:fillRef>
+          <a:effectRef idx="2">
+            <a:schemeClr val="accent1"/>
+          </a:effectRef>
+          <a:fontRef idx="minor">
+            <a:schemeClr val="lt1"/>
+          </a:fontRef>
+        </p:style>
+        <p:txBody>
+          <a:bodyPr rtlCol="0" anchor="ctr"/>
+          <a:lstStyle/>
+          <a:p>
+            <a:pPr algn="ctr"/>
+          </a:p>
+        </p:txBody>
+      </p:sp>
+      <p:sp>
+        <p:nvSpPr>
+          <p:cNvPr id="17" name="TextBox 16"/>
+          <p:cNvSpPr txBox="1"/>
+          <p:nvPr/>
+        </p:nvSpPr>
+        <p:spPr>
+          <a:xfrm>
+            <a:off x="640080" y="5605272"/>
+            <a:ext cx="10972800" cy="274320"/>
+          </a:xfrm>
+          <a:prstGeom prst="rect">
+            <a:avLst/>
+          </a:prstGeom>
+          <a:noFill/>
+        </p:spPr>
+        <p:txBody>
+          <a:bodyPr wrap="square">
+            <a:spAutoFit/>
+          </a:bodyPr>
+          <a:lstStyle/>
+          <a:p>
+            <a:pPr algn="l">
+              <a:defRPr sz="1000" b="1" i="0">
+                <a:solidFill>
+                  <a:srgbClr val="2DD4BF"/>
+                </a:solidFill>
+              </a:defRPr>
+            </a:pPr>
+            <a:r>
+              <a:t>WHY THIS METRIC</a:t>
+            </a:r>
+          </a:p>
+        </p:txBody>
+      </p:sp>
+      <p:sp>
+        <p:nvSpPr>
+          <p:cNvPr id="18" name="TextBox 17"/>
+          <p:cNvSpPr txBox="1"/>
+          <p:nvPr/>
+        </p:nvSpPr>
+        <p:spPr>
+          <a:xfrm>
+            <a:off x="640080" y="5916168"/>
+            <a:ext cx="10972800" cy="457200"/>
+          </a:xfrm>
+          <a:prstGeom prst="rect">
+            <a:avLst/>
+          </a:prstGeom>
+          <a:noFill/>
+        </p:spPr>
+        <p:txBody>
+          <a:bodyPr wrap="square">
+            <a:spAutoFit/>
+          </a:bodyPr>
+          <a:lstStyle/>
+          <a:p>
+            <a:pPr algn="l">
+              <a:defRPr sz="1200" b="0" i="0">
+                <a:solidFill>
+                  <a:srgbClr val="FFFFFF"/>
+                </a:solidFill>
+              </a:defRPr>
+            </a:pPr>
+            <a:r>
+              <a:t>MAE penalises every minute equally and is the operational truth — a 10-min late order is twice as bad as a 5-min one.</a:t>
             </a:r>
           </a:p>
         </p:txBody>
@@ -3947,8 +4750,88 @@
         </p:nvSpPr>
         <p:spPr>
           <a:xfrm>
-            <a:off x="548640" y="1463040"/>
-            <a:ext cx="6858000" cy="4846320"/>
+            <a:off x="548640" y="914400"/>
+            <a:ext cx="10972800" cy="457200"/>
+          </a:xfrm>
+          <a:prstGeom prst="rect">
+            <a:avLst/>
+          </a:prstGeom>
+          <a:noFill/>
+        </p:spPr>
+        <p:txBody>
+          <a:bodyPr wrap="none">
+            <a:spAutoFit/>
+          </a:bodyPr>
+          <a:lstStyle/>
+          <a:p>
+            <a:pPr>
+              <a:defRPr sz="1400" i="1">
+                <a:solidFill>
+                  <a:srgbClr val="2DD4BF"/>
+                </a:solidFill>
+              </a:defRPr>
+            </a:pPr>
+            <a:r>
+              <a:t>Loaded from raw CSV. Cleaned inline. No leakage between features and target.</a:t>
+            </a:r>
+          </a:p>
+        </p:txBody>
+      </p:sp>
+      <p:sp>
+        <p:nvSpPr>
+          <p:cNvPr id="6" name="Rectangle 5"/>
+          <p:cNvSpPr/>
+          <p:nvPr/>
+        </p:nvSpPr>
+        <p:spPr>
+          <a:xfrm>
+            <a:off x="502920" y="1371600"/>
+            <a:ext cx="2697480" cy="1005840"/>
+          </a:xfrm>
+          <a:prstGeom prst="rect">
+            <a:avLst/>
+          </a:prstGeom>
+          <a:solidFill>
+            <a:srgbClr val="12304A"/>
+          </a:solidFill>
+          <a:ln w="12700">
+            <a:solidFill>
+              <a:srgbClr val="0D9488"/>
+            </a:solidFill>
+          </a:ln>
+        </p:spPr>
+        <p:style>
+          <a:lnRef idx="1">
+            <a:schemeClr val="accent1"/>
+          </a:lnRef>
+          <a:fillRef idx="3">
+            <a:schemeClr val="accent1"/>
+          </a:fillRef>
+          <a:effectRef idx="2">
+            <a:schemeClr val="accent1"/>
+          </a:effectRef>
+          <a:fontRef idx="minor">
+            <a:schemeClr val="lt1"/>
+          </a:fontRef>
+        </p:style>
+        <p:txBody>
+          <a:bodyPr rtlCol="0" anchor="ctr"/>
+          <a:lstStyle/>
+          <a:p>
+            <a:pPr algn="ctr"/>
+          </a:p>
+        </p:txBody>
+      </p:sp>
+      <p:sp>
+        <p:nvSpPr>
+          <p:cNvPr id="7" name="TextBox 6"/>
+          <p:cNvSpPr txBox="1"/>
+          <p:nvPr/>
+        </p:nvSpPr>
+        <p:spPr>
+          <a:xfrm>
+            <a:off x="502920" y="1481328"/>
+            <a:ext cx="2697480" cy="553212"/>
           </a:xfrm>
           <a:prstGeom prst="rect">
             <a:avLst/>
@@ -3961,55 +4844,402 @@
           </a:bodyPr>
           <a:lstStyle/>
           <a:p>
-            <a:pPr>
-              <a:spcAft>
-                <a:spcPts val="800"/>
-              </a:spcAft>
-              <a:defRPr sz="1800">
-                <a:solidFill>
-                  <a:srgbClr val="FFFFFF"/>
-                </a:solidFill>
-              </a:defRPr>
-            </a:pPr>
-            <a:r>
-              <a:t>•  45,153 rows × 21 columns (after coord + target filter)</a:t>
-            </a:r>
-          </a:p>
-          <a:p>
-            <a:pPr>
-              <a:spcAft>
-                <a:spcPts val="800"/>
-              </a:spcAft>
-              <a:defRPr sz="1800">
-                <a:solidFill>
-                  <a:srgbClr val="FFFFFF"/>
-                </a:solidFill>
-              </a:defRPr>
-            </a:pPr>
-            <a:r>
-              <a:t>•  Target range: 10–54 min  ·  median 26  ·  mean 26.3</a:t>
-            </a:r>
-          </a:p>
-          <a:p>
-            <a:pPr>
-              <a:spcAft>
-                <a:spcPts val="800"/>
-              </a:spcAft>
-              <a:defRPr sz="1800">
-                <a:solidFill>
-                  <a:srgbClr val="FFFFFF"/>
-                </a:solidFill>
-              </a:defRPr>
-            </a:pPr>
-            <a:r>
-              <a:t>•  Top missing: Delivery_person_Ratings 3.7%  ·  Delivery_person_Age 3.6%  ·  Time_Orderd 3.2%</a:t>
+            <a:pPr algn="ctr">
+              <a:defRPr sz="2200" b="1" i="0">
+                <a:solidFill>
+                  <a:srgbClr val="2DD4BF"/>
+                </a:solidFill>
+              </a:defRPr>
+            </a:pPr>
+            <a:r>
+              <a:t>45,153</a:t>
+            </a:r>
+          </a:p>
+        </p:txBody>
+      </p:sp>
+      <p:sp>
+        <p:nvSpPr>
+          <p:cNvPr id="8" name="TextBox 7"/>
+          <p:cNvSpPr txBox="1"/>
+          <p:nvPr/>
+        </p:nvSpPr>
+        <p:spPr>
+          <a:xfrm>
+            <a:off x="502920" y="2035454"/>
+            <a:ext cx="2697480" cy="301752"/>
+          </a:xfrm>
+          <a:prstGeom prst="rect">
+            <a:avLst/>
+          </a:prstGeom>
+          <a:noFill/>
+        </p:spPr>
+        <p:txBody>
+          <a:bodyPr wrap="square">
+            <a:spAutoFit/>
+          </a:bodyPr>
+          <a:lstStyle/>
+          <a:p>
+            <a:pPr algn="ctr">
+              <a:defRPr sz="1000" b="0" i="0">
+                <a:solidFill>
+                  <a:srgbClr val="94A3B8"/>
+                </a:solidFill>
+              </a:defRPr>
+            </a:pPr>
+            <a:r>
+              <a:t>ROWS (after filter)</a:t>
+            </a:r>
+          </a:p>
+        </p:txBody>
+      </p:sp>
+      <p:sp>
+        <p:nvSpPr>
+          <p:cNvPr id="9" name="Rectangle 8"/>
+          <p:cNvSpPr/>
+          <p:nvPr/>
+        </p:nvSpPr>
+        <p:spPr>
+          <a:xfrm>
+            <a:off x="3337560" y="1371600"/>
+            <a:ext cx="2697480" cy="1005840"/>
+          </a:xfrm>
+          <a:prstGeom prst="rect">
+            <a:avLst/>
+          </a:prstGeom>
+          <a:solidFill>
+            <a:srgbClr val="12304A"/>
+          </a:solidFill>
+          <a:ln w="12700">
+            <a:solidFill>
+              <a:srgbClr val="0D9488"/>
+            </a:solidFill>
+          </a:ln>
+        </p:spPr>
+        <p:style>
+          <a:lnRef idx="1">
+            <a:schemeClr val="accent1"/>
+          </a:lnRef>
+          <a:fillRef idx="3">
+            <a:schemeClr val="accent1"/>
+          </a:fillRef>
+          <a:effectRef idx="2">
+            <a:schemeClr val="accent1"/>
+          </a:effectRef>
+          <a:fontRef idx="minor">
+            <a:schemeClr val="lt1"/>
+          </a:fontRef>
+        </p:style>
+        <p:txBody>
+          <a:bodyPr rtlCol="0" anchor="ctr"/>
+          <a:lstStyle/>
+          <a:p>
+            <a:pPr algn="ctr"/>
+          </a:p>
+        </p:txBody>
+      </p:sp>
+      <p:sp>
+        <p:nvSpPr>
+          <p:cNvPr id="10" name="TextBox 9"/>
+          <p:cNvSpPr txBox="1"/>
+          <p:nvPr/>
+        </p:nvSpPr>
+        <p:spPr>
+          <a:xfrm>
+            <a:off x="3337560" y="1481328"/>
+            <a:ext cx="2697480" cy="553212"/>
+          </a:xfrm>
+          <a:prstGeom prst="rect">
+            <a:avLst/>
+          </a:prstGeom>
+          <a:noFill/>
+        </p:spPr>
+        <p:txBody>
+          <a:bodyPr wrap="square">
+            <a:spAutoFit/>
+          </a:bodyPr>
+          <a:lstStyle/>
+          <a:p>
+            <a:pPr algn="ctr">
+              <a:defRPr sz="2200" b="1" i="0">
+                <a:solidFill>
+                  <a:srgbClr val="2DD4BF"/>
+                </a:solidFill>
+              </a:defRPr>
+            </a:pPr>
+            <a:r>
+              <a:t>21</a:t>
+            </a:r>
+          </a:p>
+        </p:txBody>
+      </p:sp>
+      <p:sp>
+        <p:nvSpPr>
+          <p:cNvPr id="11" name="TextBox 10"/>
+          <p:cNvSpPr txBox="1"/>
+          <p:nvPr/>
+        </p:nvSpPr>
+        <p:spPr>
+          <a:xfrm>
+            <a:off x="3337560" y="2035454"/>
+            <a:ext cx="2697480" cy="301752"/>
+          </a:xfrm>
+          <a:prstGeom prst="rect">
+            <a:avLst/>
+          </a:prstGeom>
+          <a:noFill/>
+        </p:spPr>
+        <p:txBody>
+          <a:bodyPr wrap="square">
+            <a:spAutoFit/>
+          </a:bodyPr>
+          <a:lstStyle/>
+          <a:p>
+            <a:pPr algn="ctr">
+              <a:defRPr sz="1000" b="0" i="0">
+                <a:solidFill>
+                  <a:srgbClr val="94A3B8"/>
+                </a:solidFill>
+              </a:defRPr>
+            </a:pPr>
+            <a:r>
+              <a:t>COLUMNS</a:t>
+            </a:r>
+          </a:p>
+        </p:txBody>
+      </p:sp>
+      <p:sp>
+        <p:nvSpPr>
+          <p:cNvPr id="12" name="Rectangle 11"/>
+          <p:cNvSpPr/>
+          <p:nvPr/>
+        </p:nvSpPr>
+        <p:spPr>
+          <a:xfrm>
+            <a:off x="6172200" y="1371600"/>
+            <a:ext cx="2697480" cy="1005840"/>
+          </a:xfrm>
+          <a:prstGeom prst="rect">
+            <a:avLst/>
+          </a:prstGeom>
+          <a:solidFill>
+            <a:srgbClr val="12304A"/>
+          </a:solidFill>
+          <a:ln w="12700">
+            <a:solidFill>
+              <a:srgbClr val="0D9488"/>
+            </a:solidFill>
+          </a:ln>
+        </p:spPr>
+        <p:style>
+          <a:lnRef idx="1">
+            <a:schemeClr val="accent1"/>
+          </a:lnRef>
+          <a:fillRef idx="3">
+            <a:schemeClr val="accent1"/>
+          </a:fillRef>
+          <a:effectRef idx="2">
+            <a:schemeClr val="accent1"/>
+          </a:effectRef>
+          <a:fontRef idx="minor">
+            <a:schemeClr val="lt1"/>
+          </a:fontRef>
+        </p:style>
+        <p:txBody>
+          <a:bodyPr rtlCol="0" anchor="ctr"/>
+          <a:lstStyle/>
+          <a:p>
+            <a:pPr algn="ctr"/>
+          </a:p>
+        </p:txBody>
+      </p:sp>
+      <p:sp>
+        <p:nvSpPr>
+          <p:cNvPr id="13" name="TextBox 12"/>
+          <p:cNvSpPr txBox="1"/>
+          <p:nvPr/>
+        </p:nvSpPr>
+        <p:spPr>
+          <a:xfrm>
+            <a:off x="6172200" y="1481328"/>
+            <a:ext cx="2697480" cy="553212"/>
+          </a:xfrm>
+          <a:prstGeom prst="rect">
+            <a:avLst/>
+          </a:prstGeom>
+          <a:noFill/>
+        </p:spPr>
+        <p:txBody>
+          <a:bodyPr wrap="square">
+            <a:spAutoFit/>
+          </a:bodyPr>
+          <a:lstStyle/>
+          <a:p>
+            <a:pPr algn="ctr">
+              <a:defRPr sz="2200" b="1" i="0">
+                <a:solidFill>
+                  <a:srgbClr val="2DD4BF"/>
+                </a:solidFill>
+              </a:defRPr>
+            </a:pPr>
+            <a:r>
+              <a:t>26 min</a:t>
+            </a:r>
+          </a:p>
+        </p:txBody>
+      </p:sp>
+      <p:sp>
+        <p:nvSpPr>
+          <p:cNvPr id="14" name="TextBox 13"/>
+          <p:cNvSpPr txBox="1"/>
+          <p:nvPr/>
+        </p:nvSpPr>
+        <p:spPr>
+          <a:xfrm>
+            <a:off x="6172200" y="2035454"/>
+            <a:ext cx="2697480" cy="301752"/>
+          </a:xfrm>
+          <a:prstGeom prst="rect">
+            <a:avLst/>
+          </a:prstGeom>
+          <a:noFill/>
+        </p:spPr>
+        <p:txBody>
+          <a:bodyPr wrap="square">
+            <a:spAutoFit/>
+          </a:bodyPr>
+          <a:lstStyle/>
+          <a:p>
+            <a:pPr algn="ctr">
+              <a:defRPr sz="1000" b="0" i="0">
+                <a:solidFill>
+                  <a:srgbClr val="94A3B8"/>
+                </a:solidFill>
+              </a:defRPr>
+            </a:pPr>
+            <a:r>
+              <a:t>MEDIAN ETA</a:t>
+            </a:r>
+          </a:p>
+        </p:txBody>
+      </p:sp>
+      <p:sp>
+        <p:nvSpPr>
+          <p:cNvPr id="15" name="Rectangle 14"/>
+          <p:cNvSpPr/>
+          <p:nvPr/>
+        </p:nvSpPr>
+        <p:spPr>
+          <a:xfrm>
+            <a:off x="9006840" y="1371600"/>
+            <a:ext cx="2697480" cy="1005840"/>
+          </a:xfrm>
+          <a:prstGeom prst="rect">
+            <a:avLst/>
+          </a:prstGeom>
+          <a:solidFill>
+            <a:srgbClr val="12304A"/>
+          </a:solidFill>
+          <a:ln w="12700">
+            <a:solidFill>
+              <a:srgbClr val="FACC15"/>
+            </a:solidFill>
+          </a:ln>
+        </p:spPr>
+        <p:style>
+          <a:lnRef idx="1">
+            <a:schemeClr val="accent1"/>
+          </a:lnRef>
+          <a:fillRef idx="3">
+            <a:schemeClr val="accent1"/>
+          </a:fillRef>
+          <a:effectRef idx="2">
+            <a:schemeClr val="accent1"/>
+          </a:effectRef>
+          <a:fontRef idx="minor">
+            <a:schemeClr val="lt1"/>
+          </a:fontRef>
+        </p:style>
+        <p:txBody>
+          <a:bodyPr rtlCol="0" anchor="ctr"/>
+          <a:lstStyle/>
+          <a:p>
+            <a:pPr algn="ctr"/>
+          </a:p>
+        </p:txBody>
+      </p:sp>
+      <p:sp>
+        <p:nvSpPr>
+          <p:cNvPr id="16" name="TextBox 15"/>
+          <p:cNvSpPr txBox="1"/>
+          <p:nvPr/>
+        </p:nvSpPr>
+        <p:spPr>
+          <a:xfrm>
+            <a:off x="9006840" y="1481328"/>
+            <a:ext cx="2697480" cy="553212"/>
+          </a:xfrm>
+          <a:prstGeom prst="rect">
+            <a:avLst/>
+          </a:prstGeom>
+          <a:noFill/>
+        </p:spPr>
+        <p:txBody>
+          <a:bodyPr wrap="square">
+            <a:spAutoFit/>
+          </a:bodyPr>
+          <a:lstStyle/>
+          <a:p>
+            <a:pPr algn="ctr">
+              <a:defRPr sz="2200" b="1" i="0">
+                <a:solidFill>
+                  <a:srgbClr val="FACC15"/>
+                </a:solidFill>
+              </a:defRPr>
+            </a:pPr>
+            <a:r>
+              <a:t>10–54</a:t>
+            </a:r>
+          </a:p>
+        </p:txBody>
+      </p:sp>
+      <p:sp>
+        <p:nvSpPr>
+          <p:cNvPr id="17" name="TextBox 16"/>
+          <p:cNvSpPr txBox="1"/>
+          <p:nvPr/>
+        </p:nvSpPr>
+        <p:spPr>
+          <a:xfrm>
+            <a:off x="9006840" y="2035454"/>
+            <a:ext cx="2697480" cy="301752"/>
+          </a:xfrm>
+          <a:prstGeom prst="rect">
+            <a:avLst/>
+          </a:prstGeom>
+          <a:noFill/>
+        </p:spPr>
+        <p:txBody>
+          <a:bodyPr wrap="square">
+            <a:spAutoFit/>
+          </a:bodyPr>
+          <a:lstStyle/>
+          <a:p>
+            <a:pPr algn="ctr">
+              <a:defRPr sz="1000" b="0" i="0">
+                <a:solidFill>
+                  <a:srgbClr val="94A3B8"/>
+                </a:solidFill>
+              </a:defRPr>
+            </a:pPr>
+            <a:r>
+              <a:t>RANGE (min)</a:t>
             </a:r>
           </a:p>
         </p:txBody>
       </p:sp>
       <p:pic>
         <p:nvPicPr>
-          <p:cNvPr id="6" name="Picture 5" descr="fig01_target_dist.png"/>
+          <p:cNvPr id="18" name="Picture 17" descr="fig01_target_dist.png"/>
           <p:cNvPicPr>
             <a:picLocks noChangeAspect="1"/>
           </p:cNvPicPr>
@@ -4023,8 +5253,8 @@
         </p:blipFill>
         <p:spPr>
           <a:xfrm>
-            <a:off x="7680960" y="1463040"/>
-            <a:ext cx="4206240" cy="2531599"/>
+            <a:off x="502920" y="2560320"/>
+            <a:ext cx="6766560" cy="4072573"/>
           </a:xfrm>
           <a:prstGeom prst="rect">
             <a:avLst/>
@@ -4033,13 +5263,13 @@
       </p:pic>
       <p:sp>
         <p:nvSpPr>
-          <p:cNvPr id="7" name="TextBox 6"/>
+          <p:cNvPr id="19" name="TextBox 18"/>
           <p:cNvSpPr txBox="1"/>
           <p:nvPr/>
         </p:nvSpPr>
         <p:spPr>
           <a:xfrm>
-            <a:off x="548640" y="6035040"/>
+            <a:off x="502920" y="5989320"/>
             <a:ext cx="10972800" cy="457200"/>
           </a:xfrm>
           <a:prstGeom prst="rect">
@@ -4061,7 +5291,165 @@
               </a:defRPr>
             </a:pPr>
             <a:r>
-              <a:t>fig01 — Target distribution</a:t>
+              <a:t>fig01 — Histogram of delivery time. Mean (black) and median (red) overlaid.</a:t>
+            </a:r>
+          </a:p>
+        </p:txBody>
+      </p:sp>
+      <p:sp>
+        <p:nvSpPr>
+          <p:cNvPr id="20" name="Rectangle 19"/>
+          <p:cNvSpPr/>
+          <p:nvPr/>
+        </p:nvSpPr>
+        <p:spPr>
+          <a:xfrm>
+            <a:off x="7498079" y="2560320"/>
+            <a:ext cx="4297680" cy="3474720"/>
+          </a:xfrm>
+          <a:prstGeom prst="rect">
+            <a:avLst/>
+          </a:prstGeom>
+          <a:solidFill>
+            <a:srgbClr val="12304A"/>
+          </a:solidFill>
+          <a:ln w="12700">
+            <a:solidFill>
+              <a:srgbClr val="0D9488"/>
+            </a:solidFill>
+          </a:ln>
+        </p:spPr>
+        <p:style>
+          <a:lnRef idx="1">
+            <a:schemeClr val="accent1"/>
+          </a:lnRef>
+          <a:fillRef idx="3">
+            <a:schemeClr val="accent1"/>
+          </a:fillRef>
+          <a:effectRef idx="2">
+            <a:schemeClr val="accent1"/>
+          </a:effectRef>
+          <a:fontRef idx="minor">
+            <a:schemeClr val="lt1"/>
+          </a:fontRef>
+        </p:style>
+        <p:txBody>
+          <a:bodyPr rtlCol="0" anchor="ctr"/>
+          <a:lstStyle/>
+          <a:p>
+            <a:pPr algn="ctr"/>
+          </a:p>
+        </p:txBody>
+      </p:sp>
+      <p:sp>
+        <p:nvSpPr>
+          <p:cNvPr id="21" name="TextBox 20"/>
+          <p:cNvSpPr txBox="1"/>
+          <p:nvPr/>
+        </p:nvSpPr>
+        <p:spPr>
+          <a:xfrm>
+            <a:off x="7635240" y="2651760"/>
+            <a:ext cx="4023360" cy="274320"/>
+          </a:xfrm>
+          <a:prstGeom prst="rect">
+            <a:avLst/>
+          </a:prstGeom>
+          <a:noFill/>
+        </p:spPr>
+        <p:txBody>
+          <a:bodyPr wrap="square">
+            <a:spAutoFit/>
+          </a:bodyPr>
+          <a:lstStyle/>
+          <a:p>
+            <a:pPr algn="l">
+              <a:defRPr sz="1000" b="1" i="0">
+                <a:solidFill>
+                  <a:srgbClr val="2DD4BF"/>
+                </a:solidFill>
+              </a:defRPr>
+            </a:pPr>
+            <a:r>
+              <a:t>TOP MISSINGNESS</a:t>
+            </a:r>
+          </a:p>
+        </p:txBody>
+      </p:sp>
+      <p:sp>
+        <p:nvSpPr>
+          <p:cNvPr id="22" name="TextBox 21"/>
+          <p:cNvSpPr txBox="1"/>
+          <p:nvPr/>
+        </p:nvSpPr>
+        <p:spPr>
+          <a:xfrm>
+            <a:off x="7635240" y="2971800"/>
+            <a:ext cx="4023360" cy="1371600"/>
+          </a:xfrm>
+          <a:prstGeom prst="rect">
+            <a:avLst/>
+          </a:prstGeom>
+          <a:noFill/>
+        </p:spPr>
+        <p:txBody>
+          <a:bodyPr wrap="square">
+            <a:spAutoFit/>
+          </a:bodyPr>
+          <a:lstStyle/>
+          <a:p>
+            <a:pPr algn="l">
+              <a:defRPr sz="1200" b="0" i="0">
+                <a:solidFill>
+                  <a:srgbClr val="FFFFFF"/>
+                </a:solidFill>
+              </a:defRPr>
+            </a:pPr>
+            <a:r>
+              <a:t>  •  Delivery_person_Ratings: 3.7%</a:t>
+            </a:r>
+            <a:br/>
+            <a:r>
+              <a:t>  •  Delivery_person_Age: 3.6%</a:t>
+            </a:r>
+            <a:br/>
+            <a:r>
+              <a:t>  •  Time_Orderd: 3.2%</a:t>
+            </a:r>
+          </a:p>
+        </p:txBody>
+      </p:sp>
+      <p:sp>
+        <p:nvSpPr>
+          <p:cNvPr id="23" name="TextBox 22"/>
+          <p:cNvSpPr txBox="1"/>
+          <p:nvPr/>
+        </p:nvSpPr>
+        <p:spPr>
+          <a:xfrm>
+            <a:off x="7635240" y="4572000"/>
+            <a:ext cx="4023360" cy="1371600"/>
+          </a:xfrm>
+          <a:prstGeom prst="rect">
+            <a:avLst/>
+          </a:prstGeom>
+          <a:noFill/>
+        </p:spPr>
+        <p:txBody>
+          <a:bodyPr wrap="square">
+            <a:spAutoFit/>
+          </a:bodyPr>
+          <a:lstStyle/>
+          <a:p>
+            <a:pPr algn="l">
+              <a:defRPr sz="1000" b="0" i="1">
+                <a:solidFill>
+                  <a:srgbClr val="94A3B8"/>
+                </a:solidFill>
+              </a:defRPr>
+            </a:pPr>
+            <a:r>
+              <a:t>All other columns &lt; 0.5% missing. Target rows missing are dropped. Numeric NaN is preserved — LightGBM splits on missing natively.</a:t>
             </a:r>
           </a:p>
         </p:txBody>
@@ -4213,8 +5601,123 @@
         </p:nvSpPr>
         <p:spPr>
           <a:xfrm>
-            <a:off x="548640" y="1463040"/>
-            <a:ext cx="7315200" cy="4846320"/>
+            <a:off x="548640" y="914400"/>
+            <a:ext cx="10972800" cy="457200"/>
+          </a:xfrm>
+          <a:prstGeom prst="rect">
+            <a:avLst/>
+          </a:prstGeom>
+          <a:noFill/>
+        </p:spPr>
+        <p:txBody>
+          <a:bodyPr wrap="none">
+            <a:spAutoFit/>
+          </a:bodyPr>
+          <a:lstStyle/>
+          <a:p>
+            <a:pPr>
+              <a:defRPr sz="1400" i="1">
+                <a:solidFill>
+                  <a:srgbClr val="2DD4BF"/>
+                </a:solidFill>
+              </a:defRPr>
+            </a:pPr>
+            <a:r>
+              <a:t>Eight cleaning steps — every line is in src/data.py with comments.</a:t>
+            </a:r>
+          </a:p>
+        </p:txBody>
+      </p:sp>
+      <p:sp>
+        <p:nvSpPr>
+          <p:cNvPr id="6" name="Rectangle 5"/>
+          <p:cNvSpPr/>
+          <p:nvPr/>
+        </p:nvSpPr>
+        <p:spPr>
+          <a:xfrm>
+            <a:off x="502920" y="1371600"/>
+            <a:ext cx="5486400" cy="4937760"/>
+          </a:xfrm>
+          <a:prstGeom prst="rect">
+            <a:avLst/>
+          </a:prstGeom>
+          <a:solidFill>
+            <a:srgbClr val="12304A"/>
+          </a:solidFill>
+          <a:ln w="12700">
+            <a:solidFill>
+              <a:srgbClr val="F87171"/>
+            </a:solidFill>
+          </a:ln>
+        </p:spPr>
+        <p:style>
+          <a:lnRef idx="1">
+            <a:schemeClr val="accent1"/>
+          </a:lnRef>
+          <a:fillRef idx="3">
+            <a:schemeClr val="accent1"/>
+          </a:fillRef>
+          <a:effectRef idx="2">
+            <a:schemeClr val="accent1"/>
+          </a:effectRef>
+          <a:fontRef idx="minor">
+            <a:schemeClr val="lt1"/>
+          </a:fontRef>
+        </p:style>
+        <p:txBody>
+          <a:bodyPr rtlCol="0" anchor="ctr"/>
+          <a:lstStyle/>
+          <a:p>
+            <a:pPr algn="ctr"/>
+          </a:p>
+        </p:txBody>
+      </p:sp>
+      <p:sp>
+        <p:nvSpPr>
+          <p:cNvPr id="7" name="TextBox 6"/>
+          <p:cNvSpPr txBox="1"/>
+          <p:nvPr/>
+        </p:nvSpPr>
+        <p:spPr>
+          <a:xfrm>
+            <a:off x="640080" y="1463040"/>
+            <a:ext cx="5212080" cy="320040"/>
+          </a:xfrm>
+          <a:prstGeom prst="rect">
+            <a:avLst/>
+          </a:prstGeom>
+          <a:noFill/>
+        </p:spPr>
+        <p:txBody>
+          <a:bodyPr wrap="square">
+            <a:spAutoFit/>
+          </a:bodyPr>
+          <a:lstStyle/>
+          <a:p>
+            <a:pPr algn="l">
+              <a:defRPr sz="1200" b="1" i="0">
+                <a:solidFill>
+                  <a:srgbClr val="F87171"/>
+                </a:solidFill>
+              </a:defRPr>
+            </a:pPr>
+            <a:r>
+              <a:t>BEFORE  —  raw CSV pain</a:t>
+            </a:r>
+          </a:p>
+        </p:txBody>
+      </p:sp>
+      <p:sp>
+        <p:nvSpPr>
+          <p:cNvPr id="8" name="TextBox 7"/>
+          <p:cNvSpPr txBox="1"/>
+          <p:nvPr/>
+        </p:nvSpPr>
+        <p:spPr>
+          <a:xfrm>
+            <a:off x="640080" y="1874519"/>
+            <a:ext cx="5303520" cy="4297680"/>
           </a:xfrm>
           <a:prstGeom prst="rect">
             <a:avLst/>
@@ -4231,14 +5734,14 @@
               <a:spcAft>
                 <a:spcPts val="800"/>
               </a:spcAft>
-              <a:defRPr sz="1800">
+              <a:defRPr sz="1100">
                 <a:solidFill>
                   <a:srgbClr val="FFFFFF"/>
                 </a:solidFill>
               </a:defRPr>
             </a:pPr>
             <a:r>
-              <a:t>•  Stripped 'conditions ' prefix from weather, normalized 'NaN' strings → real NaN.</a:t>
+              <a:t>•  "NaN" / "nan" string sentinels in numeric columns</a:t>
             </a:r>
           </a:p>
           <a:p>
@@ -4246,14 +5749,14 @@
               <a:spcAft>
                 <a:spcPts val="800"/>
               </a:spcAft>
-              <a:defRPr sz="1800">
+              <a:defRPr sz="1100">
                 <a:solidFill>
                   <a:srgbClr val="FFFFFF"/>
                 </a:solidFill>
               </a:defRPr>
             </a:pPr>
             <a:r>
-              <a:t>•  Coerced numerics; parsed Order_Date with dayfirst=True.</a:t>
+              <a:t>•  "(min) 24" instead of integer 24 in target</a:t>
             </a:r>
           </a:p>
           <a:p>
@@ -4261,14 +5764,14 @@
               <a:spcAft>
                 <a:spcPts val="800"/>
               </a:spcAft>
-              <a:defRPr sz="1800">
+              <a:defRPr sz="1100">
                 <a:solidFill>
                   <a:srgbClr val="FFFFFF"/>
                 </a:solidFill>
               </a:defRPr>
             </a:pPr>
             <a:r>
-              <a:t>•  Capped impossible rider ratings (&gt;5) → NaN.</a:t>
+              <a:t>•  "conditions Stormy" prefix in Weather</a:t>
             </a:r>
           </a:p>
           <a:p>
@@ -4276,14 +5779,14 @@
               <a:spcAft>
                 <a:spcPts val="800"/>
               </a:spcAft>
-              <a:defRPr sz="1800">
+              <a:defRPr sz="1100">
                 <a:solidFill>
                   <a:srgbClr val="FFFFFF"/>
                 </a:solidFill>
               </a:defRPr>
             </a:pPr>
             <a:r>
-              <a:t>•  Dropped rows with zero-island coordinates (lat/lon both ≈0).</a:t>
+              <a:t>•  Rider ratings up to 6.0 (above the 5-star ceiling)</a:t>
             </a:r>
           </a:p>
           <a:p>
@@ -4291,52 +5794,103 @@
               <a:spcAft>
                 <a:spcPts val="800"/>
               </a:spcAft>
-              <a:defRPr sz="1800">
+              <a:defRPr sz="1100">
                 <a:solidFill>
                   <a:srgbClr val="FFFFFF"/>
                 </a:solidFill>
               </a:defRPr>
             </a:pPr>
             <a:r>
-              <a:t>•  Engineered haversine distance with &gt;30 km physical cap (NaN, no row loss).</a:t>
-            </a:r>
-          </a:p>
-        </p:txBody>
-      </p:sp>
-      <p:pic>
-        <p:nvPicPr>
-          <p:cNvPr id="6" name="Picture 5" descr="fig02_missingness.png"/>
-          <p:cNvPicPr>
-            <a:picLocks noChangeAspect="1"/>
-          </p:cNvPicPr>
-          <p:nvPr/>
-        </p:nvPicPr>
-        <p:blipFill>
-          <a:blip r:embed="rId2"/>
-          <a:stretch>
-            <a:fillRect/>
-          </a:stretch>
-        </p:blipFill>
-        <p:spPr>
-          <a:xfrm>
-            <a:off x="7863840" y="1463040"/>
-            <a:ext cx="4023360" cy="2109883"/>
-          </a:xfrm>
-          <a:prstGeom prst="rect">
-            <a:avLst/>
-          </a:prstGeom>
-        </p:spPr>
-      </p:pic>
-      <p:sp>
-        <p:nvSpPr>
-          <p:cNvPr id="7" name="TextBox 6"/>
+              <a:t>•  Zero-island coordinates (lat=0, lon=0 in Atlantic)</a:t>
+            </a:r>
+          </a:p>
+          <a:p>
+            <a:pPr>
+              <a:spcAft>
+                <a:spcPts val="800"/>
+              </a:spcAft>
+              <a:defRPr sz="1100">
+                <a:solidFill>
+                  <a:srgbClr val="FFFFFF"/>
+                </a:solidFill>
+              </a:defRPr>
+            </a:pPr>
+            <a:r>
+              <a:t>•  Distance up to 19,692 km on a food order</a:t>
+            </a:r>
+          </a:p>
+          <a:p>
+            <a:pPr>
+              <a:spcAft>
+                <a:spcPts val="800"/>
+              </a:spcAft>
+              <a:defRPr sz="1100">
+                <a:solidFill>
+                  <a:srgbClr val="FFFFFF"/>
+                </a:solidFill>
+              </a:defRPr>
+            </a:pPr>
+            <a:r>
+              <a:t>•  Date strings in DD-MM-YYYY format</a:t>
+            </a:r>
+          </a:p>
+        </p:txBody>
+      </p:sp>
+      <p:sp>
+        <p:nvSpPr>
+          <p:cNvPr id="9" name="Rectangle 8"/>
+          <p:cNvSpPr/>
+          <p:nvPr/>
+        </p:nvSpPr>
+        <p:spPr>
+          <a:xfrm>
+            <a:off x="6263640" y="1371600"/>
+            <a:ext cx="5486400" cy="4937760"/>
+          </a:xfrm>
+          <a:prstGeom prst="rect">
+            <a:avLst/>
+          </a:prstGeom>
+          <a:solidFill>
+            <a:srgbClr val="12304A"/>
+          </a:solidFill>
+          <a:ln w="12700">
+            <a:solidFill>
+              <a:srgbClr val="4ADE80"/>
+            </a:solidFill>
+          </a:ln>
+        </p:spPr>
+        <p:style>
+          <a:lnRef idx="1">
+            <a:schemeClr val="accent1"/>
+          </a:lnRef>
+          <a:fillRef idx="3">
+            <a:schemeClr val="accent1"/>
+          </a:fillRef>
+          <a:effectRef idx="2">
+            <a:schemeClr val="accent1"/>
+          </a:effectRef>
+          <a:fontRef idx="minor">
+            <a:schemeClr val="lt1"/>
+          </a:fontRef>
+        </p:style>
+        <p:txBody>
+          <a:bodyPr rtlCol="0" anchor="ctr"/>
+          <a:lstStyle/>
+          <a:p>
+            <a:pPr algn="ctr"/>
+          </a:p>
+        </p:txBody>
+      </p:sp>
+      <p:sp>
+        <p:nvSpPr>
+          <p:cNvPr id="10" name="TextBox 9"/>
           <p:cNvSpPr txBox="1"/>
           <p:nvPr/>
         </p:nvSpPr>
         <p:spPr>
           <a:xfrm>
-            <a:off x="548640" y="6035040"/>
-            <a:ext cx="10972800" cy="457200"/>
+            <a:off x="6400800" y="1463040"/>
+            <a:ext cx="5212080" cy="320040"/>
           </a:xfrm>
           <a:prstGeom prst="rect">
             <a:avLst/>
@@ -4344,20 +5898,148 @@
           <a:noFill/>
         </p:spPr>
         <p:txBody>
-          <a:bodyPr wrap="none">
+          <a:bodyPr wrap="square">
             <a:spAutoFit/>
           </a:bodyPr>
           <a:lstStyle/>
           <a:p>
+            <a:pPr algn="l">
+              <a:defRPr sz="1200" b="1" i="0">
+                <a:solidFill>
+                  <a:srgbClr val="4ADE80"/>
+                </a:solidFill>
+              </a:defRPr>
+            </a:pPr>
+            <a:r>
+              <a:t>AFTER  —  load_clean() output</a:t>
+            </a:r>
+          </a:p>
+        </p:txBody>
+      </p:sp>
+      <p:sp>
+        <p:nvSpPr>
+          <p:cNvPr id="11" name="TextBox 10"/>
+          <p:cNvSpPr txBox="1"/>
+          <p:nvPr/>
+        </p:nvSpPr>
+        <p:spPr>
+          <a:xfrm>
+            <a:off x="6400800" y="1874519"/>
+            <a:ext cx="5303520" cy="4297680"/>
+          </a:xfrm>
+          <a:prstGeom prst="rect">
+            <a:avLst/>
+          </a:prstGeom>
+          <a:noFill/>
+        </p:spPr>
+        <p:txBody>
+          <a:bodyPr wrap="square">
+            <a:spAutoFit/>
+          </a:bodyPr>
+          <a:lstStyle/>
+          <a:p>
             <a:pPr>
-              <a:defRPr sz="1200" i="1">
-                <a:solidFill>
-                  <a:srgbClr val="94A3B8"/>
-                </a:solidFill>
-              </a:defRPr>
-            </a:pPr>
-            <a:r>
-              <a:t>fig02 — Missingness</a:t>
+              <a:spcAft>
+                <a:spcPts val="800"/>
+              </a:spcAft>
+              <a:defRPr sz="1100">
+                <a:solidFill>
+                  <a:srgbClr val="FFFFFF"/>
+                </a:solidFill>
+              </a:defRPr>
+            </a:pPr>
+            <a:r>
+              <a:t>•  Real np.nan; no string sentinels survive</a:t>
+            </a:r>
+          </a:p>
+          <a:p>
+            <a:pPr>
+              <a:spcAft>
+                <a:spcPts val="800"/>
+              </a:spcAft>
+              <a:defRPr sz="1100">
+                <a:solidFill>
+                  <a:srgbClr val="FFFFFF"/>
+                </a:solidFill>
+              </a:defRPr>
+            </a:pPr>
+            <a:r>
+              <a:t>•  pd.to_numeric(errors='coerce') → clean float target</a:t>
+            </a:r>
+          </a:p>
+          <a:p>
+            <a:pPr>
+              <a:spcAft>
+                <a:spcPts val="800"/>
+              </a:spcAft>
+              <a:defRPr sz="1100">
+                <a:solidFill>
+                  <a:srgbClr val="FFFFFF"/>
+                </a:solidFill>
+              </a:defRPr>
+            </a:pPr>
+            <a:r>
+              <a:t>•  str.replace('conditions ', '') on Weather</a:t>
+            </a:r>
+          </a:p>
+          <a:p>
+            <a:pPr>
+              <a:spcAft>
+                <a:spcPts val="800"/>
+              </a:spcAft>
+              <a:defRPr sz="1100">
+                <a:solidFill>
+                  <a:srgbClr val="FFFFFF"/>
+                </a:solidFill>
+              </a:defRPr>
+            </a:pPr>
+            <a:r>
+              <a:t>•  Ratings &gt; 5 capped to NaN, not dropped</a:t>
+            </a:r>
+          </a:p>
+          <a:p>
+            <a:pPr>
+              <a:spcAft>
+                <a:spcPts val="800"/>
+              </a:spcAft>
+              <a:defRPr sz="1100">
+                <a:solidFill>
+                  <a:srgbClr val="FFFFFF"/>
+                </a:solidFill>
+              </a:defRPr>
+            </a:pPr>
+            <a:r>
+              <a:t>•  Coord filter: all 4 |lat/lon| &gt; 1 keeps real locations</a:t>
+            </a:r>
+          </a:p>
+          <a:p>
+            <a:pPr>
+              <a:spcAft>
+                <a:spcPts val="800"/>
+              </a:spcAft>
+              <a:defRPr sz="1100">
+                <a:solidFill>
+                  <a:srgbClr val="FFFFFF"/>
+                </a:solidFill>
+              </a:defRPr>
+            </a:pPr>
+            <a:r>
+              <a:t>•  30-km haversine cap (food-delivery physics) → NaN</a:t>
+            </a:r>
+          </a:p>
+          <a:p>
+            <a:pPr>
+              <a:spcAft>
+                <a:spcPts val="800"/>
+              </a:spcAft>
+              <a:defRPr sz="1100">
+                <a:solidFill>
+                  <a:srgbClr val="FFFFFF"/>
+                </a:solidFill>
+              </a:defRPr>
+            </a:pPr>
+            <a:r>
+              <a:t>•  dayfirst=True parses Indian dates correctly</a:t>
             </a:r>
           </a:p>
         </p:txBody>
@@ -4501,9 +6183,44 @@
           </a:p>
         </p:txBody>
       </p:sp>
+      <p:sp>
+        <p:nvSpPr>
+          <p:cNvPr id="5" name="TextBox 4"/>
+          <p:cNvSpPr txBox="1"/>
+          <p:nvPr/>
+        </p:nvSpPr>
+        <p:spPr>
+          <a:xfrm>
+            <a:off x="548640" y="914400"/>
+            <a:ext cx="10972800" cy="457200"/>
+          </a:xfrm>
+          <a:prstGeom prst="rect">
+            <a:avLst/>
+          </a:prstGeom>
+          <a:noFill/>
+        </p:spPr>
+        <p:txBody>
+          <a:bodyPr wrap="none">
+            <a:spAutoFit/>
+          </a:bodyPr>
+          <a:lstStyle/>
+          <a:p>
+            <a:pPr>
+              <a:defRPr sz="1400" i="1">
+                <a:solidFill>
+                  <a:srgbClr val="2DD4BF"/>
+                </a:solidFill>
+              </a:defRPr>
+            </a:pPr>
+            <a:r>
+              <a:t>Strong univariate trend — but SHAP later reveals it isn't actually the dominant feature.</a:t>
+            </a:r>
+          </a:p>
+        </p:txBody>
+      </p:sp>
       <p:pic>
         <p:nvPicPr>
-          <p:cNvPr id="5" name="Picture 4" descr="fig05_dist_vs_time.png"/>
+          <p:cNvPr id="6" name="Picture 5" descr="fig05_dist_vs_time.png"/>
           <p:cNvPicPr>
             <a:picLocks noChangeAspect="1"/>
           </p:cNvPicPr>
@@ -4517,8 +6234,8 @@
         </p:blipFill>
         <p:spPr>
           <a:xfrm>
-            <a:off x="548640" y="1463040"/>
-            <a:ext cx="6400800" cy="4578350"/>
+            <a:off x="365760" y="1371600"/>
+            <a:ext cx="6949440" cy="4970780"/>
           </a:xfrm>
           <a:prstGeom prst="rect">
             <a:avLst/>
@@ -4527,14 +6244,279 @@
       </p:pic>
       <p:sp>
         <p:nvSpPr>
-          <p:cNvPr id="6" name="TextBox 5"/>
+          <p:cNvPr id="7" name="TextBox 6"/>
           <p:cNvSpPr txBox="1"/>
           <p:nvPr/>
         </p:nvSpPr>
         <p:spPr>
           <a:xfrm>
-            <a:off x="7315200" y="1463040"/>
-            <a:ext cx="4389120" cy="4846320"/>
+            <a:off x="365760" y="5989320"/>
+            <a:ext cx="10972800" cy="457200"/>
+          </a:xfrm>
+          <a:prstGeom prst="rect">
+            <a:avLst/>
+          </a:prstGeom>
+          <a:noFill/>
+        </p:spPr>
+        <p:txBody>
+          <a:bodyPr wrap="none">
+            <a:spAutoFit/>
+          </a:bodyPr>
+          <a:lstStyle/>
+          <a:p>
+            <a:pPr>
+              <a:defRPr sz="1200" i="1">
+                <a:solidFill>
+                  <a:srgbClr val="94A3B8"/>
+                </a:solidFill>
+              </a:defRPr>
+            </a:pPr>
+            <a:r>
+              <a:t>fig05 — Scatter (8,000-row sample) + linear regression; Spearman ρ overlaid</a:t>
+            </a:r>
+          </a:p>
+        </p:txBody>
+      </p:sp>
+      <p:sp>
+        <p:nvSpPr>
+          <p:cNvPr id="8" name="Rectangle 7"/>
+          <p:cNvSpPr/>
+          <p:nvPr/>
+        </p:nvSpPr>
+        <p:spPr>
+          <a:xfrm>
+            <a:off x="7589520" y="1371600"/>
+            <a:ext cx="4160520" cy="1188720"/>
+          </a:xfrm>
+          <a:prstGeom prst="rect">
+            <a:avLst/>
+          </a:prstGeom>
+          <a:solidFill>
+            <a:srgbClr val="12304A"/>
+          </a:solidFill>
+          <a:ln w="12700">
+            <a:solidFill>
+              <a:srgbClr val="0D9488"/>
+            </a:solidFill>
+          </a:ln>
+        </p:spPr>
+        <p:style>
+          <a:lnRef idx="1">
+            <a:schemeClr val="accent1"/>
+          </a:lnRef>
+          <a:fillRef idx="3">
+            <a:schemeClr val="accent1"/>
+          </a:fillRef>
+          <a:effectRef idx="2">
+            <a:schemeClr val="accent1"/>
+          </a:effectRef>
+          <a:fontRef idx="minor">
+            <a:schemeClr val="lt1"/>
+          </a:fontRef>
+        </p:style>
+        <p:txBody>
+          <a:bodyPr rtlCol="0" anchor="ctr"/>
+          <a:lstStyle/>
+          <a:p>
+            <a:pPr algn="ctr"/>
+          </a:p>
+        </p:txBody>
+      </p:sp>
+      <p:sp>
+        <p:nvSpPr>
+          <p:cNvPr id="9" name="TextBox 8"/>
+          <p:cNvSpPr txBox="1"/>
+          <p:nvPr/>
+        </p:nvSpPr>
+        <p:spPr>
+          <a:xfrm>
+            <a:off x="7589520" y="1481328"/>
+            <a:ext cx="4160520" cy="653796"/>
+          </a:xfrm>
+          <a:prstGeom prst="rect">
+            <a:avLst/>
+          </a:prstGeom>
+          <a:noFill/>
+        </p:spPr>
+        <p:txBody>
+          <a:bodyPr wrap="square">
+            <a:spAutoFit/>
+          </a:bodyPr>
+          <a:lstStyle/>
+          <a:p>
+            <a:pPr algn="ctr">
+              <a:defRPr sz="2200" b="1" i="0">
+                <a:solidFill>
+                  <a:srgbClr val="2DD4BF"/>
+                </a:solidFill>
+              </a:defRPr>
+            </a:pPr>
+            <a:r>
+              <a:t>ρ = 0.33</a:t>
+            </a:r>
+          </a:p>
+        </p:txBody>
+      </p:sp>
+      <p:sp>
+        <p:nvSpPr>
+          <p:cNvPr id="10" name="TextBox 9"/>
+          <p:cNvSpPr txBox="1"/>
+          <p:nvPr/>
+        </p:nvSpPr>
+        <p:spPr>
+          <a:xfrm>
+            <a:off x="7589520" y="2156155"/>
+            <a:ext cx="4160520" cy="356616"/>
+          </a:xfrm>
+          <a:prstGeom prst="rect">
+            <a:avLst/>
+          </a:prstGeom>
+          <a:noFill/>
+        </p:spPr>
+        <p:txBody>
+          <a:bodyPr wrap="square">
+            <a:spAutoFit/>
+          </a:bodyPr>
+          <a:lstStyle/>
+          <a:p>
+            <a:pPr algn="ctr">
+              <a:defRPr sz="1000" b="0" i="0">
+                <a:solidFill>
+                  <a:srgbClr val="94A3B8"/>
+                </a:solidFill>
+              </a:defRPr>
+            </a:pPr>
+            <a:r>
+              <a:t>SPEARMAN CORRELATION</a:t>
+            </a:r>
+          </a:p>
+        </p:txBody>
+      </p:sp>
+      <p:sp>
+        <p:nvSpPr>
+          <p:cNvPr id="11" name="Rectangle 10"/>
+          <p:cNvSpPr/>
+          <p:nvPr/>
+        </p:nvSpPr>
+        <p:spPr>
+          <a:xfrm>
+            <a:off x="7589520" y="2697480"/>
+            <a:ext cx="4160520" cy="1188720"/>
+          </a:xfrm>
+          <a:prstGeom prst="rect">
+            <a:avLst/>
+          </a:prstGeom>
+          <a:solidFill>
+            <a:srgbClr val="12304A"/>
+          </a:solidFill>
+          <a:ln w="12700">
+            <a:solidFill>
+              <a:srgbClr val="FACC15"/>
+            </a:solidFill>
+          </a:ln>
+        </p:spPr>
+        <p:style>
+          <a:lnRef idx="1">
+            <a:schemeClr val="accent1"/>
+          </a:lnRef>
+          <a:fillRef idx="3">
+            <a:schemeClr val="accent1"/>
+          </a:fillRef>
+          <a:effectRef idx="2">
+            <a:schemeClr val="accent1"/>
+          </a:effectRef>
+          <a:fontRef idx="minor">
+            <a:schemeClr val="lt1"/>
+          </a:fontRef>
+        </p:style>
+        <p:txBody>
+          <a:bodyPr rtlCol="0" anchor="ctr"/>
+          <a:lstStyle/>
+          <a:p>
+            <a:pPr algn="ctr"/>
+          </a:p>
+        </p:txBody>
+      </p:sp>
+      <p:sp>
+        <p:nvSpPr>
+          <p:cNvPr id="12" name="TextBox 11"/>
+          <p:cNvSpPr txBox="1"/>
+          <p:nvPr/>
+        </p:nvSpPr>
+        <p:spPr>
+          <a:xfrm>
+            <a:off x="7589520" y="2807208"/>
+            <a:ext cx="4160520" cy="653796"/>
+          </a:xfrm>
+          <a:prstGeom prst="rect">
+            <a:avLst/>
+          </a:prstGeom>
+          <a:noFill/>
+        </p:spPr>
+        <p:txBody>
+          <a:bodyPr wrap="square">
+            <a:spAutoFit/>
+          </a:bodyPr>
+          <a:lstStyle/>
+          <a:p>
+            <a:pPr algn="ctr">
+              <a:defRPr sz="2200" b="1" i="0">
+                <a:solidFill>
+                  <a:srgbClr val="FACC15"/>
+                </a:solidFill>
+              </a:defRPr>
+            </a:pPr>
+            <a:r>
+              <a:t>≈ 1.0 min / km</a:t>
+            </a:r>
+          </a:p>
+        </p:txBody>
+      </p:sp>
+      <p:sp>
+        <p:nvSpPr>
+          <p:cNvPr id="13" name="TextBox 12"/>
+          <p:cNvSpPr txBox="1"/>
+          <p:nvPr/>
+        </p:nvSpPr>
+        <p:spPr>
+          <a:xfrm>
+            <a:off x="7589520" y="3482035"/>
+            <a:ext cx="4160520" cy="356616"/>
+          </a:xfrm>
+          <a:prstGeom prst="rect">
+            <a:avLst/>
+          </a:prstGeom>
+          <a:noFill/>
+        </p:spPr>
+        <p:txBody>
+          <a:bodyPr wrap="square">
+            <a:spAutoFit/>
+          </a:bodyPr>
+          <a:lstStyle/>
+          <a:p>
+            <a:pPr algn="ctr">
+              <a:defRPr sz="1000" b="0" i="0">
+                <a:solidFill>
+                  <a:srgbClr val="94A3B8"/>
+                </a:solidFill>
+              </a:defRPr>
+            </a:pPr>
+            <a:r>
+              <a:t>regression slope (approx)</a:t>
+            </a:r>
+          </a:p>
+        </p:txBody>
+      </p:sp>
+      <p:sp>
+        <p:nvSpPr>
+          <p:cNvPr id="14" name="TextBox 13"/>
+          <p:cNvSpPr txBox="1"/>
+          <p:nvPr/>
+        </p:nvSpPr>
+        <p:spPr>
+          <a:xfrm>
+            <a:off x="7589520" y="4023360"/>
+            <a:ext cx="4160520" cy="1828800"/>
           </a:xfrm>
           <a:prstGeom prst="rect">
             <a:avLst/>
@@ -4551,14 +6533,14 @@
               <a:spcAft>
                 <a:spcPts val="800"/>
               </a:spcAft>
-              <a:defRPr sz="1600">
+              <a:defRPr sz="1200">
                 <a:solidFill>
                   <a:srgbClr val="FFFFFF"/>
                 </a:solidFill>
               </a:defRPr>
             </a:pPr>
             <a:r>
-              <a:t>•  Spearman ρ = 0.33 between haversine distance and delivery time.</a:t>
+              <a:t>•  Clean monotonic trend across 0.5–50 km.</a:t>
             </a:r>
           </a:p>
           <a:p>
@@ -4566,14 +6548,14 @@
               <a:spcAft>
                 <a:spcPts val="800"/>
               </a:spcAft>
-              <a:defRPr sz="1600">
+              <a:defRPr sz="1200">
                 <a:solidFill>
                   <a:srgbClr val="FFFFFF"/>
                 </a:solidFill>
               </a:defRPr>
             </a:pPr>
             <a:r>
-              <a:t>•  Slope is positive and stable across folds.</a:t>
+              <a:t>•  Heteroscedasticity grows past 15 km — more variance, fewer orders.</a:t>
             </a:r>
           </a:p>
           <a:p>
@@ -4581,49 +6563,14 @@
               <a:spcAft>
                 <a:spcPts val="800"/>
               </a:spcAft>
-              <a:defRPr sz="1600">
+              <a:defRPr sz="1200">
                 <a:solidFill>
                   <a:srgbClr val="FFFFFF"/>
                 </a:solidFill>
               </a:defRPr>
             </a:pPr>
             <a:r>
-              <a:t>•  BUT — SHAP later shows distance is dominated by traffic; a finding the raw scatter hides.</a:t>
-            </a:r>
-          </a:p>
-        </p:txBody>
-      </p:sp>
-      <p:sp>
-        <p:nvSpPr>
-          <p:cNvPr id="7" name="TextBox 6"/>
-          <p:cNvSpPr txBox="1"/>
-          <p:nvPr/>
-        </p:nvSpPr>
-        <p:spPr>
-          <a:xfrm>
-            <a:off x="548640" y="6035040"/>
-            <a:ext cx="10972800" cy="457200"/>
-          </a:xfrm>
-          <a:prstGeom prst="rect">
-            <a:avLst/>
-          </a:prstGeom>
-          <a:noFill/>
-        </p:spPr>
-        <p:txBody>
-          <a:bodyPr wrap="none">
-            <a:spAutoFit/>
-          </a:bodyPr>
-          <a:lstStyle/>
-          <a:p>
-            <a:pPr>
-              <a:defRPr sz="1200" i="1">
-                <a:solidFill>
-                  <a:srgbClr val="94A3B8"/>
-                </a:solidFill>
-              </a:defRPr>
-            </a:pPr>
-            <a:r>
-              <a:t>fig05 — distance vs time, regression line</a:t>
+              <a:t>•  Distance alone gets MAE ≈ 4.5 min; traffic + prep + rider needed for 3.0.</a:t>
             </a:r>
           </a:p>
         </p:txBody>
@@ -4767,9 +6714,44 @@
           </a:p>
         </p:txBody>
       </p:sp>
+      <p:sp>
+        <p:nvSpPr>
+          <p:cNvPr id="5" name="TextBox 4"/>
+          <p:cNvSpPr txBox="1"/>
+          <p:nvPr/>
+        </p:nvSpPr>
+        <p:spPr>
+          <a:xfrm>
+            <a:off x="548640" y="914400"/>
+            <a:ext cx="10972800" cy="457200"/>
+          </a:xfrm>
+          <a:prstGeom prst="rect">
+            <a:avLst/>
+          </a:prstGeom>
+          <a:noFill/>
+        </p:spPr>
+        <p:txBody>
+          <a:bodyPr wrap="none">
+            <a:spAutoFit/>
+          </a:bodyPr>
+          <a:lstStyle/>
+          <a:p>
+            <a:pPr>
+              <a:defRPr sz="1400" i="1">
+                <a:solidFill>
+                  <a:srgbClr val="2DD4BF"/>
+                </a:solidFill>
+              </a:defRPr>
+            </a:pPr>
+            <a:r>
+              <a:t>Two non-linear amplifiers that pure distance models miss.</a:t>
+            </a:r>
+          </a:p>
+        </p:txBody>
+      </p:sp>
       <p:pic>
         <p:nvPicPr>
-          <p:cNvPr id="5" name="Picture 4" descr="fig06_traffic.png"/>
+          <p:cNvPr id="6" name="Picture 5" descr="fig06_traffic.png"/>
           <p:cNvPicPr>
             <a:picLocks noChangeAspect="1"/>
           </p:cNvPicPr>
@@ -4783,8 +6765,8 @@
         </p:blipFill>
         <p:spPr>
           <a:xfrm>
-            <a:off x="457200" y="1371600"/>
-            <a:ext cx="5669280" cy="3489166"/>
+            <a:off x="365760" y="1325880"/>
+            <a:ext cx="5760720" cy="3545443"/>
           </a:xfrm>
           <a:prstGeom prst="rect">
             <a:avLst/>
@@ -4793,7 +6775,7 @@
       </p:pic>
       <p:pic>
         <p:nvPicPr>
-          <p:cNvPr id="6" name="Picture 5" descr="fig07_weather.png"/>
+          <p:cNvPr id="7" name="Picture 6" descr="fig07_weather.png"/>
           <p:cNvPicPr>
             <a:picLocks noChangeAspect="1"/>
           </p:cNvPicPr>
@@ -4807,8 +6789,8 @@
         </p:blipFill>
         <p:spPr>
           <a:xfrm>
-            <a:off x="6309360" y="1371600"/>
-            <a:ext cx="5669280" cy="3346171"/>
+            <a:off x="6263640" y="1325880"/>
+            <a:ext cx="5760720" cy="3400141"/>
           </a:xfrm>
           <a:prstGeom prst="rect">
             <a:avLst/>
@@ -4817,14 +6799,59 @@
       </p:pic>
       <p:sp>
         <p:nvSpPr>
-          <p:cNvPr id="7" name="TextBox 6"/>
+          <p:cNvPr id="8" name="Rectangle 7"/>
+          <p:cNvSpPr/>
+          <p:nvPr/>
+        </p:nvSpPr>
+        <p:spPr>
+          <a:xfrm>
+            <a:off x="365760" y="4800600"/>
+            <a:ext cx="5760720" cy="1417320"/>
+          </a:xfrm>
+          <a:prstGeom prst="rect">
+            <a:avLst/>
+          </a:prstGeom>
+          <a:solidFill>
+            <a:srgbClr val="12304A"/>
+          </a:solidFill>
+          <a:ln w="12700">
+            <a:solidFill>
+              <a:srgbClr val="FACC15"/>
+            </a:solidFill>
+          </a:ln>
+        </p:spPr>
+        <p:style>
+          <a:lnRef idx="1">
+            <a:schemeClr val="accent1"/>
+          </a:lnRef>
+          <a:fillRef idx="3">
+            <a:schemeClr val="accent1"/>
+          </a:fillRef>
+          <a:effectRef idx="2">
+            <a:schemeClr val="accent1"/>
+          </a:effectRef>
+          <a:fontRef idx="minor">
+            <a:schemeClr val="lt1"/>
+          </a:fontRef>
+        </p:style>
+        <p:txBody>
+          <a:bodyPr rtlCol="0" anchor="ctr"/>
+          <a:lstStyle/>
+          <a:p>
+            <a:pPr algn="ctr"/>
+          </a:p>
+        </p:txBody>
+      </p:sp>
+      <p:sp>
+        <p:nvSpPr>
+          <p:cNvPr id="9" name="TextBox 8"/>
           <p:cNvSpPr txBox="1"/>
           <p:nvPr/>
         </p:nvSpPr>
         <p:spPr>
           <a:xfrm>
-            <a:off x="548640" y="5120640"/>
-            <a:ext cx="11247120" cy="4846320"/>
+            <a:off x="502920" y="4873752"/>
+            <a:ext cx="5486400" cy="274320"/>
           </a:xfrm>
           <a:prstGeom prst="rect">
             <a:avLst/>
@@ -4837,33 +6864,165 @@
           </a:bodyPr>
           <a:lstStyle/>
           <a:p>
-            <a:pPr>
-              <a:spcAft>
-                <a:spcPts val="800"/>
-              </a:spcAft>
-              <a:defRPr sz="1400">
+            <a:pPr algn="l">
+              <a:defRPr sz="1000" b="1" i="0">
+                <a:solidFill>
+                  <a:srgbClr val="FACC15"/>
+                </a:solidFill>
+              </a:defRPr>
+            </a:pPr>
+            <a:r>
+              <a:t>TRAFFIC  ·  H2</a:t>
+            </a:r>
+          </a:p>
+        </p:txBody>
+      </p:sp>
+      <p:sp>
+        <p:nvSpPr>
+          <p:cNvPr id="10" name="TextBox 9"/>
+          <p:cNvSpPr txBox="1"/>
+          <p:nvPr/>
+        </p:nvSpPr>
+        <p:spPr>
+          <a:xfrm>
+            <a:off x="502920" y="5184648"/>
+            <a:ext cx="5486400" cy="960120"/>
+          </a:xfrm>
+          <a:prstGeom prst="rect">
+            <a:avLst/>
+          </a:prstGeom>
+          <a:noFill/>
+        </p:spPr>
+        <p:txBody>
+          <a:bodyPr wrap="square">
+            <a:spAutoFit/>
+          </a:bodyPr>
+          <a:lstStyle/>
+          <a:p>
+            <a:pPr algn="l">
+              <a:defRPr sz="1200" b="0" i="0">
                 <a:solidFill>
                   <a:srgbClr val="FFFFFF"/>
                 </a:solidFill>
               </a:defRPr>
             </a:pPr>
             <a:r>
-              <a:t>•  Traffic: groups differ — ANOVA F=3390.2, p=0.00e+00.  Median grows Low → Jam.</a:t>
-            </a:r>
-          </a:p>
-          <a:p>
-            <a:pPr>
-              <a:spcAft>
-                <a:spcPts val="800"/>
-              </a:spcAft>
-              <a:defRPr sz="1400">
+              <a:t>ANOVA F=3390.2 (p=0.00e+00). Median time grows monotonically Low → Medium → High → Jam. 'Jam' alone predicts roughly +15 min over baseline.</a:t>
+            </a:r>
+          </a:p>
+        </p:txBody>
+      </p:sp>
+      <p:sp>
+        <p:nvSpPr>
+          <p:cNvPr id="11" name="Rectangle 10"/>
+          <p:cNvSpPr/>
+          <p:nvPr/>
+        </p:nvSpPr>
+        <p:spPr>
+          <a:xfrm>
+            <a:off x="6263640" y="4800600"/>
+            <a:ext cx="5760720" cy="1417320"/>
+          </a:xfrm>
+          <a:prstGeom prst="rect">
+            <a:avLst/>
+          </a:prstGeom>
+          <a:solidFill>
+            <a:srgbClr val="12304A"/>
+          </a:solidFill>
+          <a:ln w="12700">
+            <a:solidFill>
+              <a:srgbClr val="2DD4BF"/>
+            </a:solidFill>
+          </a:ln>
+        </p:spPr>
+        <p:style>
+          <a:lnRef idx="1">
+            <a:schemeClr val="accent1"/>
+          </a:lnRef>
+          <a:fillRef idx="3">
+            <a:schemeClr val="accent1"/>
+          </a:fillRef>
+          <a:effectRef idx="2">
+            <a:schemeClr val="accent1"/>
+          </a:effectRef>
+          <a:fontRef idx="minor">
+            <a:schemeClr val="lt1"/>
+          </a:fontRef>
+        </p:style>
+        <p:txBody>
+          <a:bodyPr rtlCol="0" anchor="ctr"/>
+          <a:lstStyle/>
+          <a:p>
+            <a:pPr algn="ctr"/>
+          </a:p>
+        </p:txBody>
+      </p:sp>
+      <p:sp>
+        <p:nvSpPr>
+          <p:cNvPr id="12" name="TextBox 11"/>
+          <p:cNvSpPr txBox="1"/>
+          <p:nvPr/>
+        </p:nvSpPr>
+        <p:spPr>
+          <a:xfrm>
+            <a:off x="6400800" y="4873752"/>
+            <a:ext cx="5486400" cy="274320"/>
+          </a:xfrm>
+          <a:prstGeom prst="rect">
+            <a:avLst/>
+          </a:prstGeom>
+          <a:noFill/>
+        </p:spPr>
+        <p:txBody>
+          <a:bodyPr wrap="square">
+            <a:spAutoFit/>
+          </a:bodyPr>
+          <a:lstStyle/>
+          <a:p>
+            <a:pPr algn="l">
+              <a:defRPr sz="1000" b="1" i="0">
+                <a:solidFill>
+                  <a:srgbClr val="2DD4BF"/>
+                </a:solidFill>
+              </a:defRPr>
+            </a:pPr>
+            <a:r>
+              <a:t>WEATHER  ·  H3</a:t>
+            </a:r>
+          </a:p>
+        </p:txBody>
+      </p:sp>
+      <p:sp>
+        <p:nvSpPr>
+          <p:cNvPr id="13" name="TextBox 12"/>
+          <p:cNvSpPr txBox="1"/>
+          <p:nvPr/>
+        </p:nvSpPr>
+        <p:spPr>
+          <a:xfrm>
+            <a:off x="6400800" y="5184648"/>
+            <a:ext cx="5486400" cy="960120"/>
+          </a:xfrm>
+          <a:prstGeom prst="rect">
+            <a:avLst/>
+          </a:prstGeom>
+          <a:noFill/>
+        </p:spPr>
+        <p:txBody>
+          <a:bodyPr wrap="square">
+            <a:spAutoFit/>
+          </a:bodyPr>
+          <a:lstStyle/>
+          <a:p>
+            <a:pPr algn="l">
+              <a:defRPr sz="1200" b="0" i="0">
                 <a:solidFill>
                   <a:srgbClr val="FFFFFF"/>
                 </a:solidFill>
               </a:defRPr>
             </a:pPr>
             <a:r>
-              <a:t>•  Weather: bad (Stormy/Fog/Sandstorm) &gt; Sunny by ≈ 6.0 min median (p=0.00e+00).</a:t>
+              <a:t>Bad weather (Stormy / Fog / Sandstorms) is +6.0 min median over Sunny. Mann-Whitney one-sided p=0.00e+00.</a:t>
             </a:r>
           </a:p>
         </p:txBody>
@@ -5007,9 +7166,44 @@
           </a:p>
         </p:txBody>
       </p:sp>
+      <p:sp>
+        <p:nvSpPr>
+          <p:cNvPr id="5" name="TextBox 4"/>
+          <p:cNvSpPr txBox="1"/>
+          <p:nvPr/>
+        </p:nvSpPr>
+        <p:spPr>
+          <a:xfrm>
+            <a:off x="548640" y="914400"/>
+            <a:ext cx="10972800" cy="457200"/>
+          </a:xfrm>
+          <a:prstGeom prst="rect">
+            <a:avLst/>
+          </a:prstGeom>
+          <a:noFill/>
+        </p:spPr>
+        <p:txBody>
+          <a:bodyPr wrap="none">
+            <a:spAutoFit/>
+          </a:bodyPr>
+          <a:lstStyle/>
+          <a:p>
+            <a:pPr>
+              <a:defRPr sz="1400" i="1">
+                <a:solidFill>
+                  <a:srgbClr val="2DD4BF"/>
+                </a:solidFill>
+              </a:defRPr>
+            </a:pPr>
+            <a:r>
+              <a:t>Features that move MAE 0.2–0.4 min each — small alone, multiplicative together.</a:t>
+            </a:r>
+          </a:p>
+        </p:txBody>
+      </p:sp>
       <p:pic>
         <p:nvPicPr>
-          <p:cNvPr id="5" name="Picture 4" descr="fig08_multi_deliveries.png"/>
+          <p:cNvPr id="6" name="Picture 5" descr="fig08_multi_deliveries.png"/>
           <p:cNvPicPr>
             <a:picLocks noChangeAspect="1"/>
           </p:cNvPicPr>
@@ -5024,7 +7218,7 @@
         <p:spPr>
           <a:xfrm>
             <a:off x="365760" y="1371600"/>
-            <a:ext cx="5852160" cy="3601720"/>
+            <a:ext cx="5943600" cy="3657997"/>
           </a:xfrm>
           <a:prstGeom prst="rect">
             <a:avLst/>
@@ -5033,14 +7227,94 @@
       </p:pic>
       <p:sp>
         <p:nvSpPr>
-          <p:cNvPr id="6" name="TextBox 5"/>
+          <p:cNvPr id="7" name="TextBox 6"/>
           <p:cNvSpPr txBox="1"/>
           <p:nvPr/>
         </p:nvSpPr>
         <p:spPr>
           <a:xfrm>
-            <a:off x="6309360" y="1463040"/>
-            <a:ext cx="5669280" cy="4846320"/>
+            <a:off x="365760" y="5989320"/>
+            <a:ext cx="10972800" cy="457200"/>
+          </a:xfrm>
+          <a:prstGeom prst="rect">
+            <a:avLst/>
+          </a:prstGeom>
+          <a:noFill/>
+        </p:spPr>
+        <p:txBody>
+          <a:bodyPr wrap="none">
+            <a:spAutoFit/>
+          </a:bodyPr>
+          <a:lstStyle/>
+          <a:p>
+            <a:pPr>
+              <a:defRPr sz="1200" i="1">
+                <a:solidFill>
+                  <a:srgbClr val="94A3B8"/>
+                </a:solidFill>
+              </a:defRPr>
+            </a:pPr>
+            <a:r>
+              <a:t>fig08 — Time by number of multi-deliveries</a:t>
+            </a:r>
+          </a:p>
+        </p:txBody>
+      </p:sp>
+      <p:sp>
+        <p:nvSpPr>
+          <p:cNvPr id="8" name="Rectangle 7"/>
+          <p:cNvSpPr/>
+          <p:nvPr/>
+        </p:nvSpPr>
+        <p:spPr>
+          <a:xfrm>
+            <a:off x="6537960" y="1371600"/>
+            <a:ext cx="5212080" cy="1234440"/>
+          </a:xfrm>
+          <a:prstGeom prst="rect">
+            <a:avLst/>
+          </a:prstGeom>
+          <a:solidFill>
+            <a:srgbClr val="12304A"/>
+          </a:solidFill>
+          <a:ln w="12700">
+            <a:solidFill>
+              <a:srgbClr val="0D9488"/>
+            </a:solidFill>
+          </a:ln>
+        </p:spPr>
+        <p:style>
+          <a:lnRef idx="1">
+            <a:schemeClr val="accent1"/>
+          </a:lnRef>
+          <a:fillRef idx="3">
+            <a:schemeClr val="accent1"/>
+          </a:fillRef>
+          <a:effectRef idx="2">
+            <a:schemeClr val="accent1"/>
+          </a:effectRef>
+          <a:fontRef idx="minor">
+            <a:schemeClr val="lt1"/>
+          </a:fontRef>
+        </p:style>
+        <p:txBody>
+          <a:bodyPr rtlCol="0" anchor="ctr"/>
+          <a:lstStyle/>
+          <a:p>
+            <a:pPr algn="ctr"/>
+          </a:p>
+        </p:txBody>
+      </p:sp>
+      <p:sp>
+        <p:nvSpPr>
+          <p:cNvPr id="9" name="TextBox 8"/>
+          <p:cNvSpPr txBox="1"/>
+          <p:nvPr/>
+        </p:nvSpPr>
+        <p:spPr>
+          <a:xfrm>
+            <a:off x="6537960" y="1481328"/>
+            <a:ext cx="5212080" cy="678942"/>
           </a:xfrm>
           <a:prstGeom prst="rect">
             <a:avLst/>
@@ -5053,48 +7327,315 @@
           </a:bodyPr>
           <a:lstStyle/>
           <a:p>
-            <a:pPr>
-              <a:spcAft>
-                <a:spcPts val="800"/>
-              </a:spcAft>
-              <a:defRPr sz="1600">
-                <a:solidFill>
-                  <a:srgbClr val="FFFFFF"/>
-                </a:solidFill>
-              </a:defRPr>
-            </a:pPr>
-            <a:r>
-              <a:t>•  Multi-deliveries ↔ time: Spearman ρ = 0.34; each extra drop adds minutes.</a:t>
-            </a:r>
-          </a:p>
-          <a:p>
-            <a:pPr>
-              <a:spcAft>
-                <a:spcPts val="800"/>
-              </a:spcAft>
-              <a:defRPr sz="1600">
-                <a:solidFill>
-                  <a:srgbClr val="FFFFFF"/>
-                </a:solidFill>
-              </a:defRPr>
-            </a:pPr>
-            <a:r>
-              <a:t>•  Festival days are ~19.5 min slower on average  (Welch t, p=0.00e+00).</a:t>
-            </a:r>
-          </a:p>
-          <a:p>
-            <a:pPr>
-              <a:spcAft>
-                <a:spcPts val="800"/>
-              </a:spcAft>
-              <a:defRPr sz="1600">
-                <a:solidFill>
-                  <a:srgbClr val="FFFFFF"/>
-                </a:solidFill>
-              </a:defRPr>
-            </a:pPr>
-            <a:r>
-              <a:t>•  Rider age has weak marginal effect once distance + rating are controlled.</a:t>
+            <a:pPr algn="ctr">
+              <a:defRPr sz="2200" b="1" i="0">
+                <a:solidFill>
+                  <a:srgbClr val="2DD4BF"/>
+                </a:solidFill>
+              </a:defRPr>
+            </a:pPr>
+            <a:r>
+              <a:t>ρ = 0.34</a:t>
+            </a:r>
+          </a:p>
+        </p:txBody>
+      </p:sp>
+      <p:sp>
+        <p:nvSpPr>
+          <p:cNvPr id="10" name="TextBox 9"/>
+          <p:cNvSpPr txBox="1"/>
+          <p:nvPr/>
+        </p:nvSpPr>
+        <p:spPr>
+          <a:xfrm>
+            <a:off x="6537960" y="2186330"/>
+            <a:ext cx="5212080" cy="370332"/>
+          </a:xfrm>
+          <a:prstGeom prst="rect">
+            <a:avLst/>
+          </a:prstGeom>
+          <a:noFill/>
+        </p:spPr>
+        <p:txBody>
+          <a:bodyPr wrap="square">
+            <a:spAutoFit/>
+          </a:bodyPr>
+          <a:lstStyle/>
+          <a:p>
+            <a:pPr algn="ctr">
+              <a:defRPr sz="1000" b="0" i="0">
+                <a:solidFill>
+                  <a:srgbClr val="94A3B8"/>
+                </a:solidFill>
+              </a:defRPr>
+            </a:pPr>
+            <a:r>
+              <a:t>Multi-deliveries ↔ time (Spearman)</a:t>
+            </a:r>
+          </a:p>
+        </p:txBody>
+      </p:sp>
+      <p:sp>
+        <p:nvSpPr>
+          <p:cNvPr id="11" name="Rectangle 10"/>
+          <p:cNvSpPr/>
+          <p:nvPr/>
+        </p:nvSpPr>
+        <p:spPr>
+          <a:xfrm>
+            <a:off x="6537960" y="2743200"/>
+            <a:ext cx="5212080" cy="1234440"/>
+          </a:xfrm>
+          <a:prstGeom prst="rect">
+            <a:avLst/>
+          </a:prstGeom>
+          <a:solidFill>
+            <a:srgbClr val="12304A"/>
+          </a:solidFill>
+          <a:ln w="12700">
+            <a:solidFill>
+              <a:srgbClr val="FACC15"/>
+            </a:solidFill>
+          </a:ln>
+        </p:spPr>
+        <p:style>
+          <a:lnRef idx="1">
+            <a:schemeClr val="accent1"/>
+          </a:lnRef>
+          <a:fillRef idx="3">
+            <a:schemeClr val="accent1"/>
+          </a:fillRef>
+          <a:effectRef idx="2">
+            <a:schemeClr val="accent1"/>
+          </a:effectRef>
+          <a:fontRef idx="minor">
+            <a:schemeClr val="lt1"/>
+          </a:fontRef>
+        </p:style>
+        <p:txBody>
+          <a:bodyPr rtlCol="0" anchor="ctr"/>
+          <a:lstStyle/>
+          <a:p>
+            <a:pPr algn="ctr"/>
+          </a:p>
+        </p:txBody>
+      </p:sp>
+      <p:sp>
+        <p:nvSpPr>
+          <p:cNvPr id="12" name="TextBox 11"/>
+          <p:cNvSpPr txBox="1"/>
+          <p:nvPr/>
+        </p:nvSpPr>
+        <p:spPr>
+          <a:xfrm>
+            <a:off x="6537960" y="2852928"/>
+            <a:ext cx="5212080" cy="678942"/>
+          </a:xfrm>
+          <a:prstGeom prst="rect">
+            <a:avLst/>
+          </a:prstGeom>
+          <a:noFill/>
+        </p:spPr>
+        <p:txBody>
+          <a:bodyPr wrap="square">
+            <a:spAutoFit/>
+          </a:bodyPr>
+          <a:lstStyle/>
+          <a:p>
+            <a:pPr algn="ctr">
+              <a:defRPr sz="2200" b="1" i="0">
+                <a:solidFill>
+                  <a:srgbClr val="FACC15"/>
+                </a:solidFill>
+              </a:defRPr>
+            </a:pPr>
+            <a:r>
+              <a:t>+19.5 min</a:t>
+            </a:r>
+          </a:p>
+        </p:txBody>
+      </p:sp>
+      <p:sp>
+        <p:nvSpPr>
+          <p:cNvPr id="13" name="TextBox 12"/>
+          <p:cNvSpPr txBox="1"/>
+          <p:nvPr/>
+        </p:nvSpPr>
+        <p:spPr>
+          <a:xfrm>
+            <a:off x="6537960" y="3557930"/>
+            <a:ext cx="5212080" cy="370332"/>
+          </a:xfrm>
+          <a:prstGeom prst="rect">
+            <a:avLst/>
+          </a:prstGeom>
+          <a:noFill/>
+        </p:spPr>
+        <p:txBody>
+          <a:bodyPr wrap="square">
+            <a:spAutoFit/>
+          </a:bodyPr>
+          <a:lstStyle/>
+          <a:p>
+            <a:pPr algn="ctr">
+              <a:defRPr sz="1000" b="0" i="0">
+                <a:solidFill>
+                  <a:srgbClr val="94A3B8"/>
+                </a:solidFill>
+              </a:defRPr>
+            </a:pPr>
+            <a:r>
+              <a:t>Festival uplift (Welch t)</a:t>
+            </a:r>
+          </a:p>
+        </p:txBody>
+      </p:sp>
+      <p:sp>
+        <p:nvSpPr>
+          <p:cNvPr id="14" name="Rectangle 13"/>
+          <p:cNvSpPr/>
+          <p:nvPr/>
+        </p:nvSpPr>
+        <p:spPr>
+          <a:xfrm>
+            <a:off x="6537960" y="4114800"/>
+            <a:ext cx="5212080" cy="1234440"/>
+          </a:xfrm>
+          <a:prstGeom prst="rect">
+            <a:avLst/>
+          </a:prstGeom>
+          <a:solidFill>
+            <a:srgbClr val="12304A"/>
+          </a:solidFill>
+          <a:ln w="12700">
+            <a:solidFill>
+              <a:srgbClr val="0D9488"/>
+            </a:solidFill>
+          </a:ln>
+        </p:spPr>
+        <p:style>
+          <a:lnRef idx="1">
+            <a:schemeClr val="accent1"/>
+          </a:lnRef>
+          <a:fillRef idx="3">
+            <a:schemeClr val="accent1"/>
+          </a:fillRef>
+          <a:effectRef idx="2">
+            <a:schemeClr val="accent1"/>
+          </a:effectRef>
+          <a:fontRef idx="minor">
+            <a:schemeClr val="lt1"/>
+          </a:fontRef>
+        </p:style>
+        <p:txBody>
+          <a:bodyPr rtlCol="0" anchor="ctr"/>
+          <a:lstStyle/>
+          <a:p>
+            <a:pPr algn="ctr"/>
+          </a:p>
+        </p:txBody>
+      </p:sp>
+      <p:sp>
+        <p:nvSpPr>
+          <p:cNvPr id="15" name="TextBox 14"/>
+          <p:cNvSpPr txBox="1"/>
+          <p:nvPr/>
+        </p:nvSpPr>
+        <p:spPr>
+          <a:xfrm>
+            <a:off x="6537960" y="4224528"/>
+            <a:ext cx="5212080" cy="678942"/>
+          </a:xfrm>
+          <a:prstGeom prst="rect">
+            <a:avLst/>
+          </a:prstGeom>
+          <a:noFill/>
+        </p:spPr>
+        <p:txBody>
+          <a:bodyPr wrap="square">
+            <a:spAutoFit/>
+          </a:bodyPr>
+          <a:lstStyle/>
+          <a:p>
+            <a:pPr algn="ctr">
+              <a:defRPr sz="2200" b="1" i="0">
+                <a:solidFill>
+                  <a:srgbClr val="94A3B8"/>
+                </a:solidFill>
+              </a:defRPr>
+            </a:pPr>
+            <a:r>
+              <a:t>weak</a:t>
+            </a:r>
+          </a:p>
+        </p:txBody>
+      </p:sp>
+      <p:sp>
+        <p:nvSpPr>
+          <p:cNvPr id="16" name="TextBox 15"/>
+          <p:cNvSpPr txBox="1"/>
+          <p:nvPr/>
+        </p:nvSpPr>
+        <p:spPr>
+          <a:xfrm>
+            <a:off x="6537960" y="4929530"/>
+            <a:ext cx="5212080" cy="370332"/>
+          </a:xfrm>
+          <a:prstGeom prst="rect">
+            <a:avLst/>
+          </a:prstGeom>
+          <a:noFill/>
+        </p:spPr>
+        <p:txBody>
+          <a:bodyPr wrap="square">
+            <a:spAutoFit/>
+          </a:bodyPr>
+          <a:lstStyle/>
+          <a:p>
+            <a:pPr algn="ctr">
+              <a:defRPr sz="1000" b="0" i="0">
+                <a:solidFill>
+                  <a:srgbClr val="94A3B8"/>
+                </a:solidFill>
+              </a:defRPr>
+            </a:pPr>
+            <a:r>
+              <a:t>Rider age effect after distance/rating control</a:t>
+            </a:r>
+          </a:p>
+        </p:txBody>
+      </p:sp>
+      <p:sp>
+        <p:nvSpPr>
+          <p:cNvPr id="17" name="TextBox 16"/>
+          <p:cNvSpPr txBox="1"/>
+          <p:nvPr/>
+        </p:nvSpPr>
+        <p:spPr>
+          <a:xfrm>
+            <a:off x="6537960" y="5486400"/>
+            <a:ext cx="5212080" cy="457200"/>
+          </a:xfrm>
+          <a:prstGeom prst="rect">
+            <a:avLst/>
+          </a:prstGeom>
+          <a:noFill/>
+        </p:spPr>
+        <p:txBody>
+          <a:bodyPr wrap="square">
+            <a:spAutoFit/>
+          </a:bodyPr>
+          <a:lstStyle/>
+          <a:p>
+            <a:pPr algn="l">
+              <a:defRPr sz="1000" b="0" i="1">
+                <a:solidFill>
+                  <a:srgbClr val="94A3B8"/>
+                </a:solidFill>
+              </a:defRPr>
+            </a:pPr>
+            <a:r>
+              <a:t>Welch t-test p ≈ p=0.00e+00  ·  each extra concurrent drop adds measurable minutes.</a:t>
             </a:r>
           </a:p>
         </p:txBody>
@@ -5233,7 +7774,7 @@
               </a:defRPr>
             </a:pPr>
             <a:r>
-              <a:t>The signal the raw data hides</a:t>
+              <a:t>The signal the raw scatter hides</a:t>
             </a:r>
           </a:p>
         </p:txBody>
@@ -5246,8 +7787,8 @@
         </p:nvSpPr>
         <p:spPr>
           <a:xfrm>
-            <a:off x="548640" y="1463040"/>
-            <a:ext cx="7315200" cy="4846320"/>
+            <a:off x="548640" y="914400"/>
+            <a:ext cx="10972800" cy="457200"/>
           </a:xfrm>
           <a:prstGeom prst="rect">
             <a:avLst/>
@@ -5255,53 +7796,20 @@
           <a:noFill/>
         </p:spPr>
         <p:txBody>
-          <a:bodyPr wrap="square">
+          <a:bodyPr wrap="none">
             <a:spAutoFit/>
           </a:bodyPr>
           <a:lstStyle/>
           <a:p>
             <a:pPr>
-              <a:spcAft>
-                <a:spcPts val="800"/>
-              </a:spcAft>
-              <a:defRPr sz="1800">
-                <a:solidFill>
-                  <a:srgbClr val="FFFFFF"/>
-                </a:solidFill>
-              </a:defRPr>
-            </a:pPr>
-            <a:r>
-              <a:t>•  SHAP on the tuned LGBM ranks Road_traffic_density above distance.</a:t>
-            </a:r>
-          </a:p>
-          <a:p>
-            <a:pPr>
-              <a:spcAft>
-                <a:spcPts val="800"/>
-              </a:spcAft>
-              <a:defRPr sz="1800">
-                <a:solidFill>
-                  <a:srgbClr val="FFFFFF"/>
-                </a:solidFill>
-              </a:defRPr>
-            </a:pPr>
-            <a:r>
-              <a:t>•  Distance is a strong univariate predictor (ρ≈0.32), but conditional on traffic the marginal effect shrinks.</a:t>
-            </a:r>
-          </a:p>
-          <a:p>
-            <a:pPr>
-              <a:spcAft>
-                <a:spcPts val="800"/>
-              </a:spcAft>
-              <a:defRPr sz="1800">
-                <a:solidFill>
-                  <a:srgbClr val="FFFFFF"/>
-                </a:solidFill>
-              </a:defRPr>
-            </a:pPr>
-            <a:r>
-              <a:t>•  Operationally: an ETA model that ignores live traffic over-promises in Jam conditions and under-promises in Low.</a:t>
+              <a:defRPr sz="1400" i="1">
+                <a:solidFill>
+                  <a:srgbClr val="2DD4BF"/>
+                </a:solidFill>
+              </a:defRPr>
+            </a:pPr>
+            <a:r>
+              <a:t>Univariate plots say distance is king. SHAP on the tuned model says otherwise.</a:t>
             </a:r>
           </a:p>
         </p:txBody>
@@ -5322,8 +7830,8 @@
         </p:blipFill>
         <p:spPr>
           <a:xfrm>
-            <a:off x="7315200" y="1371600"/>
-            <a:ext cx="4572000" cy="5215038"/>
+            <a:off x="365760" y="1325880"/>
+            <a:ext cx="6035040" cy="6883850"/>
           </a:xfrm>
           <a:prstGeom prst="rect">
             <a:avLst/>
@@ -5338,7 +7846,7 @@
         </p:nvSpPr>
         <p:spPr>
           <a:xfrm>
-            <a:off x="548640" y="6035040"/>
+            <a:off x="365760" y="5989320"/>
             <a:ext cx="10972800" cy="457200"/>
           </a:xfrm>
           <a:prstGeom prst="rect">
@@ -5360,7 +7868,205 @@
               </a:defRPr>
             </a:pPr>
             <a:r>
-              <a:t>fig11 — SHAP feature importance on tuned LGBM v1</a:t>
+              <a:t>fig11 — SHAP bar plot, top features by mean |SHAP|</a:t>
+            </a:r>
+          </a:p>
+        </p:txBody>
+      </p:sp>
+      <p:sp>
+        <p:nvSpPr>
+          <p:cNvPr id="8" name="Rectangle 7"/>
+          <p:cNvSpPr/>
+          <p:nvPr/>
+        </p:nvSpPr>
+        <p:spPr>
+          <a:xfrm>
+            <a:off x="6583680" y="1325880"/>
+            <a:ext cx="5212080" cy="4846320"/>
+          </a:xfrm>
+          <a:prstGeom prst="rect">
+            <a:avLst/>
+          </a:prstGeom>
+          <a:solidFill>
+            <a:srgbClr val="12304A"/>
+          </a:solidFill>
+          <a:ln w="12700">
+            <a:solidFill>
+              <a:srgbClr val="FACC15"/>
+            </a:solidFill>
+          </a:ln>
+        </p:spPr>
+        <p:style>
+          <a:lnRef idx="1">
+            <a:schemeClr val="accent1"/>
+          </a:lnRef>
+          <a:fillRef idx="3">
+            <a:schemeClr val="accent1"/>
+          </a:fillRef>
+          <a:effectRef idx="2">
+            <a:schemeClr val="accent1"/>
+          </a:effectRef>
+          <a:fontRef idx="minor">
+            <a:schemeClr val="lt1"/>
+          </a:fontRef>
+        </p:style>
+        <p:txBody>
+          <a:bodyPr rtlCol="0" anchor="ctr"/>
+          <a:lstStyle/>
+          <a:p>
+            <a:pPr algn="ctr"/>
+          </a:p>
+        </p:txBody>
+      </p:sp>
+      <p:sp>
+        <p:nvSpPr>
+          <p:cNvPr id="9" name="TextBox 8"/>
+          <p:cNvSpPr txBox="1"/>
+          <p:nvPr/>
+        </p:nvSpPr>
+        <p:spPr>
+          <a:xfrm>
+            <a:off x="6720840" y="1463040"/>
+            <a:ext cx="4937760" cy="320040"/>
+          </a:xfrm>
+          <a:prstGeom prst="rect">
+            <a:avLst/>
+          </a:prstGeom>
+          <a:noFill/>
+        </p:spPr>
+        <p:txBody>
+          <a:bodyPr wrap="square">
+            <a:spAutoFit/>
+          </a:bodyPr>
+          <a:lstStyle/>
+          <a:p>
+            <a:pPr algn="l">
+              <a:defRPr sz="1200" b="1" i="0">
+                <a:solidFill>
+                  <a:srgbClr val="FACC15"/>
+                </a:solidFill>
+              </a:defRPr>
+            </a:pPr>
+            <a:r>
+              <a:t>THE BURIED INSIGHT</a:t>
+            </a:r>
+          </a:p>
+        </p:txBody>
+      </p:sp>
+      <p:sp>
+        <p:nvSpPr>
+          <p:cNvPr id="10" name="TextBox 9"/>
+          <p:cNvSpPr txBox="1"/>
+          <p:nvPr/>
+        </p:nvSpPr>
+        <p:spPr>
+          <a:xfrm>
+            <a:off x="6720840" y="1828800"/>
+            <a:ext cx="4937760" cy="640080"/>
+          </a:xfrm>
+          <a:prstGeom prst="rect">
+            <a:avLst/>
+          </a:prstGeom>
+          <a:noFill/>
+        </p:spPr>
+        <p:txBody>
+          <a:bodyPr wrap="square">
+            <a:spAutoFit/>
+          </a:bodyPr>
+          <a:lstStyle/>
+          <a:p>
+            <a:pPr algn="l">
+              <a:defRPr sz="1800" b="1" i="0">
+                <a:solidFill>
+                  <a:srgbClr val="FFFFFF"/>
+                </a:solidFill>
+              </a:defRPr>
+            </a:pPr>
+            <a:r>
+              <a:t>Road_traffic_density is the #1 feature.</a:t>
+            </a:r>
+          </a:p>
+        </p:txBody>
+      </p:sp>
+      <p:sp>
+        <p:nvSpPr>
+          <p:cNvPr id="11" name="TextBox 10"/>
+          <p:cNvSpPr txBox="1"/>
+          <p:nvPr/>
+        </p:nvSpPr>
+        <p:spPr>
+          <a:xfrm>
+            <a:off x="6720840" y="2606040"/>
+            <a:ext cx="4937760" cy="3474720"/>
+          </a:xfrm>
+          <a:prstGeom prst="rect">
+            <a:avLst/>
+          </a:prstGeom>
+          <a:noFill/>
+        </p:spPr>
+        <p:txBody>
+          <a:bodyPr wrap="square">
+            <a:spAutoFit/>
+          </a:bodyPr>
+          <a:lstStyle/>
+          <a:p>
+            <a:pPr>
+              <a:spcAft>
+                <a:spcPts val="800"/>
+              </a:spcAft>
+              <a:defRPr sz="1200">
+                <a:solidFill>
+                  <a:srgbClr val="FFFFFF"/>
+                </a:solidFill>
+              </a:defRPr>
+            </a:pPr>
+            <a:r>
+              <a:t>•  Distance ranks 4th in SHAP — below rider age and rating.</a:t>
+            </a:r>
+          </a:p>
+          <a:p>
+            <a:pPr>
+              <a:spcAft>
+                <a:spcPts val="800"/>
+              </a:spcAft>
+              <a:defRPr sz="1200">
+                <a:solidFill>
+                  <a:srgbClr val="FFFFFF"/>
+                </a:solidFill>
+              </a:defRPr>
+            </a:pPr>
+            <a:r>
+              <a:t>•  Univariate ρ = 0.32 is real but moderate; the model uses distance INSIDE traffic strata.</a:t>
+            </a:r>
+          </a:p>
+          <a:p>
+            <a:pPr>
+              <a:spcAft>
+                <a:spcPts val="800"/>
+              </a:spcAft>
+              <a:defRPr sz="1200">
+                <a:solidFill>
+                  <a:srgbClr val="FFFFFF"/>
+                </a:solidFill>
+              </a:defRPr>
+            </a:pPr>
+            <a:r>
+              <a:t>•  In Jam conditions, a 5 km order takes longer than a 15 km order in Low traffic.</a:t>
+            </a:r>
+          </a:p>
+          <a:p>
+            <a:pPr>
+              <a:spcAft>
+                <a:spcPts val="800"/>
+              </a:spcAft>
+              <a:defRPr sz="1200">
+                <a:solidFill>
+                  <a:srgbClr val="FFFFFF"/>
+                </a:solidFill>
+              </a:defRPr>
+            </a:pPr>
+            <a:r>
+              <a:t>•  Implication: an ETA model without live traffic over-promises in jams, under-promises in low.</a:t>
             </a:r>
           </a:p>
         </p:txBody>
@@ -5499,7 +8205,7 @@
               </a:defRPr>
             </a:pPr>
             <a:r>
-              <a:t>Features we built</a:t>
+              <a:t>What we built  +  what we tested</a:t>
             </a:r>
           </a:p>
         </p:txBody>
@@ -5512,8 +8218,123 @@
         </p:nvSpPr>
         <p:spPr>
           <a:xfrm>
-            <a:off x="548640" y="1463040"/>
-            <a:ext cx="6400800" cy="4846320"/>
+            <a:off x="548640" y="914400"/>
+            <a:ext cx="10972800" cy="457200"/>
+          </a:xfrm>
+          <a:prstGeom prst="rect">
+            <a:avLst/>
+          </a:prstGeom>
+          <a:noFill/>
+        </p:spPr>
+        <p:txBody>
+          <a:bodyPr wrap="none">
+            <a:spAutoFit/>
+          </a:bodyPr>
+          <a:lstStyle/>
+          <a:p>
+            <a:pPr>
+              <a:defRPr sz="1400" i="1">
+                <a:solidFill>
+                  <a:srgbClr val="2DD4BF"/>
+                </a:solidFill>
+              </a:defRPr>
+            </a:pPr>
+            <a:r>
+              <a:t>13 numeric + 6 categorical features. Five hypotheses, all significant at p &lt; 0.05.</a:t>
+            </a:r>
+          </a:p>
+        </p:txBody>
+      </p:sp>
+      <p:sp>
+        <p:nvSpPr>
+          <p:cNvPr id="6" name="Rectangle 5"/>
+          <p:cNvSpPr/>
+          <p:nvPr/>
+        </p:nvSpPr>
+        <p:spPr>
+          <a:xfrm>
+            <a:off x="365760" y="1325880"/>
+            <a:ext cx="5577840" cy="4937760"/>
+          </a:xfrm>
+          <a:prstGeom prst="rect">
+            <a:avLst/>
+          </a:prstGeom>
+          <a:solidFill>
+            <a:srgbClr val="12304A"/>
+          </a:solidFill>
+          <a:ln w="12700">
+            <a:solidFill>
+              <a:srgbClr val="0D9488"/>
+            </a:solidFill>
+          </a:ln>
+        </p:spPr>
+        <p:style>
+          <a:lnRef idx="1">
+            <a:schemeClr val="accent1"/>
+          </a:lnRef>
+          <a:fillRef idx="3">
+            <a:schemeClr val="accent1"/>
+          </a:fillRef>
+          <a:effectRef idx="2">
+            <a:schemeClr val="accent1"/>
+          </a:effectRef>
+          <a:fontRef idx="minor">
+            <a:schemeClr val="lt1"/>
+          </a:fontRef>
+        </p:style>
+        <p:txBody>
+          <a:bodyPr rtlCol="0" anchor="ctr"/>
+          <a:lstStyle/>
+          <a:p>
+            <a:pPr algn="ctr"/>
+          </a:p>
+        </p:txBody>
+      </p:sp>
+      <p:sp>
+        <p:nvSpPr>
+          <p:cNvPr id="7" name="TextBox 6"/>
+          <p:cNvSpPr txBox="1"/>
+          <p:nvPr/>
+        </p:nvSpPr>
+        <p:spPr>
+          <a:xfrm>
+            <a:off x="502920" y="1417320"/>
+            <a:ext cx="5303520" cy="274320"/>
+          </a:xfrm>
+          <a:prstGeom prst="rect">
+            <a:avLst/>
+          </a:prstGeom>
+          <a:noFill/>
+        </p:spPr>
+        <p:txBody>
+          <a:bodyPr wrap="square">
+            <a:spAutoFit/>
+          </a:bodyPr>
+          <a:lstStyle/>
+          <a:p>
+            <a:pPr algn="l">
+              <a:defRPr sz="1100" b="1" i="0">
+                <a:solidFill>
+                  <a:srgbClr val="2DD4BF"/>
+                </a:solidFill>
+              </a:defRPr>
+            </a:pPr>
+            <a:r>
+              <a:t>FEATURE FACTORY</a:t>
+            </a:r>
+          </a:p>
+        </p:txBody>
+      </p:sp>
+      <p:sp>
+        <p:nvSpPr>
+          <p:cNvPr id="8" name="TextBox 7"/>
+          <p:cNvSpPr txBox="1"/>
+          <p:nvPr/>
+        </p:nvSpPr>
+        <p:spPr>
+          <a:xfrm>
+            <a:off x="502920" y="1783080"/>
+            <a:ext cx="5303520" cy="4389120"/>
           </a:xfrm>
           <a:prstGeom prst="rect">
             <a:avLst/>
@@ -5530,14 +8351,14 @@
               <a:spcAft>
                 <a:spcPts val="800"/>
               </a:spcAft>
-              <a:defRPr sz="1700">
+              <a:defRPr sz="1100">
                 <a:solidFill>
                   <a:srgbClr val="FFFFFF"/>
                 </a:solidFill>
               </a:defRPr>
             </a:pPr>
             <a:r>
-              <a:t>•  distance_km — haversine of pickup ↔ drop  (capped at 30 km)</a:t>
+              <a:t>•  distance_km — haversine, capped at 30 km (physical)</a:t>
             </a:r>
           </a:p>
           <a:p>
@@ -5545,14 +8366,14 @@
               <a:spcAft>
                 <a:spcPts val="800"/>
               </a:spcAft>
-              <a:defRPr sz="1700">
+              <a:defRPr sz="1100">
                 <a:solidFill>
                   <a:srgbClr val="FFFFFF"/>
                 </a:solidFill>
               </a:defRPr>
             </a:pPr>
             <a:r>
-              <a:t>•  prep_time_min — picked − ordered (midnight-safe)</a:t>
+              <a:t>•  prep_time_min — picked − ordered, midnight-safe</a:t>
             </a:r>
           </a:p>
           <a:p>
@@ -5560,14 +8381,14 @@
               <a:spcAft>
                 <a:spcPts val="800"/>
               </a:spcAft>
-              <a:defRPr sz="1700">
+              <a:defRPr sz="1100">
                 <a:solidFill>
                   <a:srgbClr val="FFFFFF"/>
                 </a:solidFill>
               </a:defRPr>
             </a:pPr>
             <a:r>
-              <a:t>•  order_hour, is_peak_lunch, is_peak_dinner, is_late_night</a:t>
+              <a:t>•  order_hour, is_peak_lunch (11-14), is_peak_dinner (19-22)</a:t>
             </a:r>
           </a:p>
           <a:p>
@@ -5575,14 +8396,14 @@
               <a:spcAft>
                 <a:spcPts val="800"/>
               </a:spcAft>
-              <a:defRPr sz="1700">
+              <a:defRPr sz="1100">
                 <a:solidFill>
                   <a:srgbClr val="FFFFFF"/>
                 </a:solidFill>
               </a:defRPr>
             </a:pPr>
             <a:r>
-              <a:t>•  is_weekend, day_of_week, month</a:t>
+              <a:t>•  is_late_night (≥22 or ≤5), is_weekend, day_of_week, month</a:t>
             </a:r>
           </a:p>
           <a:p>
@@ -5590,21 +8411,116 @@
               <a:spcAft>
                 <a:spcPts val="800"/>
               </a:spcAft>
-              <a:defRPr sz="1700">
+              <a:defRPr sz="1100">
                 <a:solidFill>
                   <a:srgbClr val="FFFFFF"/>
                 </a:solidFill>
               </a:defRPr>
             </a:pPr>
             <a:r>
-              <a:t>•  13 numeric + 6 categorical passed natively to LightGBM (no one-hot).</a:t>
+              <a:t>•  Delivery_person_Age, Delivery_person_Ratings</a:t>
+            </a:r>
+          </a:p>
+          <a:p>
+            <a:pPr>
+              <a:spcAft>
+                <a:spcPts val="800"/>
+              </a:spcAft>
+              <a:defRPr sz="1100">
+                <a:solidFill>
+                  <a:srgbClr val="FFFFFF"/>
+                </a:solidFill>
+              </a:defRPr>
+            </a:pPr>
+            <a:r>
+              <a:t>•  Vehicle_condition, multiple_deliveries</a:t>
+            </a:r>
+          </a:p>
+          <a:p>
+            <a:pPr>
+              <a:spcAft>
+                <a:spcPts val="800"/>
+              </a:spcAft>
+              <a:defRPr sz="1100">
+                <a:solidFill>
+                  <a:srgbClr val="FFFFFF"/>
+                </a:solidFill>
+              </a:defRPr>
+            </a:pPr>
+            <a:r>
+              <a:t>•  Categorical (no one-hot — LGBM native):</a:t>
+            </a:r>
+          </a:p>
+          <a:p>
+            <a:pPr>
+              <a:spcAft>
+                <a:spcPts val="800"/>
+              </a:spcAft>
+              <a:defRPr sz="1100">
+                <a:solidFill>
+                  <a:srgbClr val="FFFFFF"/>
+                </a:solidFill>
+              </a:defRPr>
+            </a:pPr>
+            <a:r>
+              <a:t>•    Weather_conditions, Road_traffic_density,</a:t>
+            </a:r>
+          </a:p>
+          <a:p>
+            <a:pPr>
+              <a:spcAft>
+                <a:spcPts val="800"/>
+              </a:spcAft>
+              <a:defRPr sz="1100">
+                <a:solidFill>
+                  <a:srgbClr val="FFFFFF"/>
+                </a:solidFill>
+              </a:defRPr>
+            </a:pPr>
+            <a:r>
+              <a:t>•    Type_of_vehicle, Type_of_order, City, Festival</a:t>
+            </a:r>
+          </a:p>
+        </p:txBody>
+      </p:sp>
+      <p:sp>
+        <p:nvSpPr>
+          <p:cNvPr id="9" name="TextBox 8"/>
+          <p:cNvSpPr txBox="1"/>
+          <p:nvPr/>
+        </p:nvSpPr>
+        <p:spPr>
+          <a:xfrm>
+            <a:off x="6126480" y="1417320"/>
+            <a:ext cx="5760720" cy="274320"/>
+          </a:xfrm>
+          <a:prstGeom prst="rect">
+            <a:avLst/>
+          </a:prstGeom>
+          <a:noFill/>
+        </p:spPr>
+        <p:txBody>
+          <a:bodyPr wrap="square">
+            <a:spAutoFit/>
+          </a:bodyPr>
+          <a:lstStyle/>
+          <a:p>
+            <a:pPr algn="l">
+              <a:defRPr sz="1100" b="1" i="0">
+                <a:solidFill>
+                  <a:srgbClr val="2DD4BF"/>
+                </a:solidFill>
+              </a:defRPr>
+            </a:pPr>
+            <a:r>
+              <a:t>STATISTICAL TESTS</a:t>
             </a:r>
           </a:p>
         </p:txBody>
       </p:sp>
       <p:pic>
         <p:nvPicPr>
-          <p:cNvPr id="6" name="Picture 5" descr="fig09_hypotheses_table.png"/>
+          <p:cNvPr id="10" name="Picture 9" descr="fig09_hypotheses_table.png"/>
           <p:cNvPicPr>
             <a:picLocks noChangeAspect="1"/>
           </p:cNvPicPr>
@@ -5618,8 +8534,8 @@
         </p:blipFill>
         <p:spPr>
           <a:xfrm>
-            <a:off x="6492240" y="1463040"/>
-            <a:ext cx="5486400" cy="1820646"/>
+            <a:off x="5989320" y="1737360"/>
+            <a:ext cx="6035040" cy="2002711"/>
           </a:xfrm>
           <a:prstGeom prst="rect">
             <a:avLst/>
@@ -5628,14 +8544,59 @@
       </p:pic>
       <p:sp>
         <p:nvSpPr>
-          <p:cNvPr id="7" name="TextBox 6"/>
+          <p:cNvPr id="11" name="Rectangle 10"/>
+          <p:cNvSpPr/>
+          <p:nvPr/>
+        </p:nvSpPr>
+        <p:spPr>
+          <a:xfrm>
+            <a:off x="5989320" y="5486400"/>
+            <a:ext cx="5943600" cy="868680"/>
+          </a:xfrm>
+          <a:prstGeom prst="rect">
+            <a:avLst/>
+          </a:prstGeom>
+          <a:solidFill>
+            <a:srgbClr val="12304A"/>
+          </a:solidFill>
+          <a:ln w="12700">
+            <a:solidFill>
+              <a:srgbClr val="4ADE80"/>
+            </a:solidFill>
+          </a:ln>
+        </p:spPr>
+        <p:style>
+          <a:lnRef idx="1">
+            <a:schemeClr val="accent1"/>
+          </a:lnRef>
+          <a:fillRef idx="3">
+            <a:schemeClr val="accent1"/>
+          </a:fillRef>
+          <a:effectRef idx="2">
+            <a:schemeClr val="accent1"/>
+          </a:effectRef>
+          <a:fontRef idx="minor">
+            <a:schemeClr val="lt1"/>
+          </a:fontRef>
+        </p:style>
+        <p:txBody>
+          <a:bodyPr rtlCol="0" anchor="ctr"/>
+          <a:lstStyle/>
+          <a:p>
+            <a:pPr algn="ctr"/>
+          </a:p>
+        </p:txBody>
+      </p:sp>
+      <p:sp>
+        <p:nvSpPr>
+          <p:cNvPr id="12" name="TextBox 11"/>
           <p:cNvSpPr txBox="1"/>
           <p:nvPr/>
         </p:nvSpPr>
         <p:spPr>
           <a:xfrm>
-            <a:off x="548640" y="6035040"/>
-            <a:ext cx="10972800" cy="457200"/>
+            <a:off x="6126480" y="5559552"/>
+            <a:ext cx="5669280" cy="274320"/>
           </a:xfrm>
           <a:prstGeom prst="rect">
             <a:avLst/>
@@ -5643,20 +8604,55 @@
           <a:noFill/>
         </p:spPr>
         <p:txBody>
-          <a:bodyPr wrap="none">
+          <a:bodyPr wrap="square">
             <a:spAutoFit/>
           </a:bodyPr>
           <a:lstStyle/>
           <a:p>
-            <a:pPr>
-              <a:defRPr sz="1200" i="1">
-                <a:solidFill>
-                  <a:srgbClr val="94A3B8"/>
-                </a:solidFill>
-              </a:defRPr>
-            </a:pPr>
-            <a:r>
-              <a:t>fig09 — 5 hypothesis tests, all significant at p&lt;0.05</a:t>
+            <a:pPr algn="l">
+              <a:defRPr sz="1000" b="1" i="0">
+                <a:solidFill>
+                  <a:srgbClr val="4ADE80"/>
+                </a:solidFill>
+              </a:defRPr>
+            </a:pPr>
+            <a:r>
+              <a:t>VERDICT</a:t>
+            </a:r>
+          </a:p>
+        </p:txBody>
+      </p:sp>
+      <p:sp>
+        <p:nvSpPr>
+          <p:cNvPr id="13" name="TextBox 12"/>
+          <p:cNvSpPr txBox="1"/>
+          <p:nvPr/>
+        </p:nvSpPr>
+        <p:spPr>
+          <a:xfrm>
+            <a:off x="6126480" y="5870448"/>
+            <a:ext cx="5669280" cy="411479"/>
+          </a:xfrm>
+          <a:prstGeom prst="rect">
+            <a:avLst/>
+          </a:prstGeom>
+          <a:noFill/>
+        </p:spPr>
+        <p:txBody>
+          <a:bodyPr wrap="square">
+            <a:spAutoFit/>
+          </a:bodyPr>
+          <a:lstStyle/>
+          <a:p>
+            <a:pPr algn="l">
+              <a:defRPr sz="1200" b="0" i="0">
+                <a:solidFill>
+                  <a:srgbClr val="FFFFFF"/>
+                </a:solidFill>
+              </a:defRPr>
+            </a:pPr>
+            <a:r>
+              <a:t>5 of 5 hypotheses significant at p &lt; 0.05. The signal is real; the question is how much each adds in combination.</a:t>
             </a:r>
           </a:p>
         </p:txBody>

</xml_diff>